<commit_message>
Rewrite slide 3 in plainer language, on top of Sandra's edits
Sandra returned the deck with her own changes to slides 1, 2 and 4:
dropped the title-slide tagline, shortened the slide 2 title, split
cyclical and compliance into separate rows, glossed Revenue as
operational expenditure, and used FYF on slide 4. This works from her
file so all of that is preserved.

Slide 3 is reworded to match that register: 'Three things I'd check
first' rather than 'Three hypotheses I would arrive with', plain card
headings, shorter sentences, and 'WHAT I'D CHECK' in place of 'THE
TEST'. Substance and sourcing unchanged; speaker notes rewritten to
match and still time at roughly 2:05.

The .pptx is now the source of truth — build_codi_deck.js produced the
original and no longer regenerates the current file.

Co-Authored-By: Claude Opus 5 <noreply@anthropic.com>
Claude-Session: https://claude.ai/code/session_01USX9SeNWtCVt7CViGP813v
</commit_message>
<xml_diff>
--- a/briefings/Codi_Presentation_Sandra_Vermaak.pptx
+++ b/briefings/Codi_Presentation_Sandra_Vermaak.pptx
@@ -4,6 +4,9 @@
   <p:sldMasterIdLst>
     <p:sldMasterId id="2147483648" r:id="rId1"/>
   </p:sldMasterIdLst>
+  <p:notesMasterIdLst>
+    <p:notesMasterId r:id="rId9"/>
+  </p:notesMasterIdLst>
   <p:sldIdLst>
     <p:sldId id="256" r:id="rId2"/>
     <p:sldId id="257" r:id="rId3"/>
@@ -13,9 +16,6 @@
     <p:sldId id="261" r:id="rId7"/>
     <p:sldId id="262" r:id="rId8"/>
   </p:sldIdLst>
-  <p:notesMasterIdLst>
-    <p:notesMasterId r:id="rId9"/>
-  </p:notesMasterIdLst>
   <p:sldSz cx="12192000" cy="6858000"/>
   <p:notesSz cx="6858000" cy="12192000"/>
   <p:defaultTextStyle>
@@ -110,6 +110,11 @@
       </a:defRPr>
     </a:lvl9pPr>
   </p:defaultTextStyle>
+  <p:extLst>
+    <p:ext uri="{EFAFB233-063F-42B5-8137-9DF3F51BA10A}">
+      <p15:sldGuideLst xmlns:p15="http://schemas.microsoft.com/office/powerpoint/2012/main"/>
+    </p:ext>
+  </p:extLst>
 </p:presentation>
 </file>
 
@@ -135,234 +140,10 @@
           <a:chExt cx="0" cy="0"/>
         </a:xfrm>
       </p:grpSpPr>
-      <p:sp>
-        <p:nvSpPr>
-          <p:cNvPr id="2" name="Header Placeholder 1"/>
-          <p:cNvSpPr>
-            <a:spLocks noGrp="1"/>
-          </p:cNvSpPr>
-          <p:nvPr>
-            <p:ph type="hdr" sz="quarter"/>
-          </p:nvPr>
-        </p:nvSpPr>
-        <p:spPr>
-          <a:xfrm>
-            <a:off x="0" y="0"/>
-            <a:ext cx="2971800" cy="458788"/>
-          </a:xfrm>
-          <a:prstGeom prst="rect">
-            <a:avLst/>
-          </a:prstGeom>
-        </p:spPr>
-        <p:txBody>
-          <a:bodyPr vert="horz" lIns="91440" tIns="45720" rIns="91440" bIns="45720" rtlCol="0"/>
-          <a:lstStyle>
-            <a:lvl1pPr algn="l">
-              <a:defRPr sz="1200"/>
-            </a:lvl1pPr>
-          </a:lstStyle>
-          <a:p>
-            <a:endParaRPr lang="en-US"/>
-          </a:p>
-        </p:txBody>
-      </p:sp>
-      <p:sp>
-        <p:nvSpPr>
-          <p:cNvPr id="3" name="Date Placeholder 2"/>
-          <p:cNvSpPr>
-            <a:spLocks noGrp="1"/>
-          </p:cNvSpPr>
-          <p:nvPr>
-            <p:ph type="dt" idx="1"/>
-          </p:nvPr>
-        </p:nvSpPr>
-        <p:spPr>
-          <a:xfrm>
-            <a:off x="3884613" y="0"/>
-            <a:ext cx="2971800" cy="458788"/>
-          </a:xfrm>
-          <a:prstGeom prst="rect">
-            <a:avLst/>
-          </a:prstGeom>
-        </p:spPr>
-        <p:txBody>
-          <a:bodyPr vert="horz" lIns="91440" tIns="45720" rIns="91440" bIns="45720" rtlCol="0"/>
-          <a:lstStyle>
-            <a:lvl1pPr algn="r">
-              <a:defRPr sz="1200"/>
-            </a:lvl1pPr>
-          </a:lstStyle>
-          <a:p>
-            <a:fld id="{5282F153-3F37-0F45-9E97-73ACFA13230C}" type="datetimeFigureOut">
-              <a:rPr lang="en-US"/>
-              <a:t>7/23/19</a:t>
-            </a:fld>
-            <a:endParaRPr lang="en-US"/>
-          </a:p>
-        </p:txBody>
-      </p:sp>
-      <p:sp>
-        <p:nvSpPr>
-          <p:cNvPr id="4" name="Slide Image Placeholder 3"/>
-          <p:cNvSpPr>
-            <a:spLocks noGrp="1" noRot="1" noChangeAspect="1"/>
-          </p:cNvSpPr>
-          <p:nvPr>
-            <p:ph type="sldImg" idx="2"/>
-          </p:nvPr>
-        </p:nvSpPr>
-        <p:spPr>
-          <a:xfrm>
-            <a:off x="685800" y="1143000"/>
-            <a:ext cx="5486400" cy="3086100"/>
-          </a:xfrm>
-          <a:prstGeom prst="rect">
-            <a:avLst/>
-          </a:prstGeom>
-          <a:noFill/>
-          <a:ln w="12700">
-            <a:solidFill>
-              <a:prstClr val="black"/>
-            </a:solidFill>
-          </a:ln>
-        </p:spPr>
-        <p:txBody>
-          <a:bodyPr vert="horz" lIns="91440" tIns="45720" rIns="91440" bIns="45720" rtlCol="0" anchor="ctr"/>
-          <a:lstStyle/>
-          <a:p>
-            <a:endParaRPr lang="en-US"/>
-          </a:p>
-        </p:txBody>
-      </p:sp>
-      <p:sp>
-        <p:nvSpPr>
-          <p:cNvPr id="5" name="Notes Placeholder 4"/>
-          <p:cNvSpPr>
-            <a:spLocks noGrp="1"/>
-          </p:cNvSpPr>
-          <p:nvPr>
-            <p:ph type="body" sz="quarter" idx="3"/>
-          </p:nvPr>
-        </p:nvSpPr>
-        <p:spPr>
-          <a:xfrm>
-            <a:off x="685800" y="4400550"/>
-            <a:ext cx="5486400" cy="3600450"/>
-          </a:xfrm>
-          <a:prstGeom prst="rect">
-            <a:avLst/>
-          </a:prstGeom>
-        </p:spPr>
-        <p:txBody>
-          <a:bodyPr vert="horz" lIns="91440" tIns="45720" rIns="91440" bIns="45720" rtlCol="0"/>
-          <a:lstStyle/>
-          <a:p>
-            <a:pPr lvl="0"/>
-            <a:r>
-              <a:rPr lang="en-US"/>
-              <a:t>Click to edit Master text styles</a:t>
-            </a:r>
-          </a:p>
-          <a:p>
-            <a:pPr lvl="1"/>
-            <a:r>
-              <a:rPr lang="en-US"/>
-              <a:t>Second level</a:t>
-            </a:r>
-          </a:p>
-          <a:p>
-            <a:pPr lvl="2"/>
-            <a:r>
-              <a:rPr lang="en-US"/>
-              <a:t>Third level</a:t>
-            </a:r>
-          </a:p>
-          <a:p>
-            <a:pPr lvl="3"/>
-            <a:r>
-              <a:rPr lang="en-US"/>
-              <a:t>Fourth level</a:t>
-            </a:r>
-          </a:p>
-          <a:p>
-            <a:pPr lvl="4"/>
-            <a:r>
-              <a:rPr lang="en-US"/>
-              <a:t>Fifth level</a:t>
-            </a:r>
-          </a:p>
-        </p:txBody>
-      </p:sp>
-      <p:sp>
-        <p:nvSpPr>
-          <p:cNvPr id="6" name="Footer Placeholder 5"/>
-          <p:cNvSpPr>
-            <a:spLocks noGrp="1"/>
-          </p:cNvSpPr>
-          <p:nvPr>
-            <p:ph type="ftr" sz="quarter" idx="4"/>
-          </p:nvPr>
-        </p:nvSpPr>
-        <p:spPr>
-          <a:xfrm>
-            <a:off x="0" y="8685213"/>
-            <a:ext cx="2971800" cy="458787"/>
-          </a:xfrm>
-          <a:prstGeom prst="rect">
-            <a:avLst/>
-          </a:prstGeom>
-        </p:spPr>
-        <p:txBody>
-          <a:bodyPr vert="horz" lIns="91440" tIns="45720" rIns="91440" bIns="45720" rtlCol="0" anchor="b"/>
-          <a:lstStyle>
-            <a:lvl1pPr algn="l">
-              <a:defRPr sz="1200"/>
-            </a:lvl1pPr>
-          </a:lstStyle>
-          <a:p>
-            <a:endParaRPr lang="en-US"/>
-          </a:p>
-        </p:txBody>
-      </p:sp>
-      <p:sp>
-        <p:nvSpPr>
-          <p:cNvPr id="7" name="Slide Number Placeholder 6"/>
-          <p:cNvSpPr>
-            <a:spLocks noGrp="1"/>
-          </p:cNvSpPr>
-          <p:nvPr>
-            <p:ph type="sldNum" sz="quarter" idx="5"/>
-          </p:nvPr>
-        </p:nvSpPr>
-        <p:spPr>
-          <a:xfrm>
-            <a:off x="3884613" y="8685213"/>
-            <a:ext cx="2971800" cy="458787"/>
-          </a:xfrm>
-          <a:prstGeom prst="rect">
-            <a:avLst/>
-          </a:prstGeom>
-        </p:spPr>
-        <p:txBody>
-          <a:bodyPr vert="horz" lIns="91440" tIns="45720" rIns="91440" bIns="45720" rtlCol="0" anchor="b"/>
-          <a:lstStyle>
-            <a:lvl1pPr algn="r">
-              <a:defRPr sz="1200"/>
-            </a:lvl1pPr>
-          </a:lstStyle>
-          <a:p>
-            <a:fld id="{CE5E9CC1-C706-0F49-92D6-E571CC5EEA8F}" type="slidenum">
-              <a:rPr lang="en-US"/>
-              <a:t>‹#›</a:t>
-            </a:fld>
-            <a:endParaRPr lang="en-US"/>
-          </a:p>
-        </p:txBody>
-      </p:sp>
     </p:spTree>
     <p:extLst>
       <p:ext uri="{BB962C8B-B14F-4D97-AF65-F5344CB8AC3E}">
-        <p14:creationId xmlns:p14="http://schemas.microsoft.com/office/powerpoint/2010/main" val="1024086991"/>
+        <p14:creationId xmlns:p14="http://schemas.microsoft.com/office/powerpoint/2010/main" val="2950222104"/>
       </p:ext>
     </p:extLst>
   </p:cSld>
@@ -513,7 +294,6 @@
 I'll cover scoping the number, the three hypotheses I'd arrive with, rebuilding the forecast with budget holders, what I'd do about it, how I'd escalate, and what I'd measure.
 One caveat. This is my recommended approach, not a claim about how Codi works today. Figures are either published or clearly illustrative, and I'll say which.</a:t>
             </a:r>
-            <a:endParaRPr lang="en-US" dirty="0"/>
           </a:p>
         </p:txBody>
       </p:sp>
@@ -605,7 +385,6 @@
 So my first question would be where that line is drawn and how consistently it is applied, particularly post-merger where two legacy capitalisation policies may still be in use. Reclassifying spend is not a saving, and I'd want to be sure no part of the position depends on it.
 [Source] Homes figure from public reporting on the merger. The £100m is the interview scenario. Category split is illustrative.</a:t>
             </a:r>
-            <a:endParaRPr lang="en-US" dirty="0"/>
           </a:p>
         </p:txBody>
       </p:sp>
@@ -690,16 +469,44 @@
           <a:lstStyle/>
           <a:p>
             <a:r>
-              <a:rPr lang="en-US" dirty="0"/>
-              <a:t>PACE 2:05  ·  Running total 4:10.
-I wouldn't arrive with an open mind and no shape. I'd bring three hypotheses and the data to kill or confirm each quickly.
-First, delivery mix. Publicly, Pobl expanded its in-house trades team by about fifty per cent in 2024, thirty-four roles, while running an eleven-lot framework for responsive repairs, voids and out-of-hours to support the internal team. Sensible model, but it is exactly where double-running appears. The test: has contractor spend fallen in proportion to the capacity brought in-house, or are we paying for both? I'd compare contractor call-off value per month against internal jobs completed and operative hours.
-Second, regulation. The WHQS hazard response requirements took effect on the first of April this year. Where harm is judged imminent you investigate within twenty-four hours and remedy within a further twenty-four; otherwise ten working days, then five. Compressed timescales push work out of hours and into premium call-off, and make it harder to batch jobs, so cost per job rises even when volume doesn't. Response times also have to be published and reported, so this is not a place to look for savings.
-Third, price. Sector surveys put expected responsive repairs increases around twenty-three per cent this year, well ahead of the ten per cent implied by the regulator's global accounts. That is UK-wide and indicative rather than Welsh, but it tells me to separate rate from volume before concluding anything about efficiency.
-If I'm wrong on all three I've still narrowed the search quickly. I'd rather be corrected in week one than confirm a number in month six.
-[Source] Pobl in-house trades announcement (2024); Pobl responsive repairs and voids framework notice, 11 lots (Dec 2023); Welsh Government WHQS responding-to-hazards statement (Dec 2025), in force 1 April 2026; UK repairs cost survey commentary. Context, not claims about Codi's position.</a:t>
-            </a:r>
-            <a:endParaRPr lang="en-US" dirty="0"/>
+              <a:t>PACE 2:05  ·  Running total 4:10.</a:t>
+            </a:r>
+          </a:p>
+          <a:p/>
+          <a:p>
+            <a:r>
+              <a:t>I wouldn't turn up with no idea what was going on. I'd come with three things I want to check, and the data I'd need to prove or rule out each one.</a:t>
+            </a:r>
+          </a:p>
+          <a:p/>
+          <a:p>
+            <a:r>
+              <a:t>First, who does the work. Pobl grew its in-house trades team by about half in 2024, thirty-four roles, and there's also a contractor framework across eleven lots covering repairs, voids and out-of-hours. That's a sensible set-up, but it's exactly where you can end up paying twice. So I'd check whether contractor spend has come down in line with the work we brought in-house, comparing it month by month against the jobs our own teams complete.</a:t>
+            </a:r>
+          </a:p>
+          <a:p/>
+          <a:p>
+            <a:r>
+              <a:t>Second, the new repair rules. Since the first of April this year, WHQS sets response times. If a hazard is urgent, it's twenty-four hours to investigate and another twenty-four to put it right. Otherwise it's ten working days, then five. Tighter deadlines mean more out-of-hours and more emergency call-outs, and they make it harder to group jobs together sensibly, so the cost per job goes up even when the number of jobs doesn't. And because response times have to be published, this isn't somewhere to look for savings.</a:t>
+            </a:r>
+          </a:p>
+          <a:p/>
+          <a:p>
+            <a:r>
+              <a:t>Third, costs going up. Across the sector, repairs costs are expected to rise by about twenty-three per cent this year, against nearer ten in the regulator's published figures. That's UK-wide rather than Welsh, so I'd use it as a reason to separate price from volume, not as a number to lean on.</a:t>
+            </a:r>
+          </a:p>
+          <a:p/>
+          <a:p>
+            <a:r>
+              <a:t>If none of the three is right, I've still narrowed it down quickly. I'd rather be put right in week one than be confident and wrong in month six.</a:t>
+            </a:r>
+          </a:p>
+          <a:p/>
+          <a:p>
+            <a:r>
+              <a:t>[Source] Pobl in-house trades announcement (2024); Pobl responsive repairs and voids framework notice, 11 lots (Dec 2023); Welsh Government WHQS responding-to-hazards statement (Dec 2025), in force 1 April 2026; UK repairs cost survey commentary. Context, not claims about Codi's position.</a:t>
+            </a:r>
           </a:p>
         </p:txBody>
       </p:sp>
@@ -791,7 +598,6 @@
 I'd record the owner and confidence level of every material assumption, and run a base case and a downside, such as sustained contractor reliance or a harder winter. The point is to show the range and identify which two or three assumptions actually move the answer.
 One discipline I'd hold firmly. The delivery forecast stays visible before mitigation. Only owned, time-phased, achievable actions come off it; anything less certain is shown separately as an opportunity. A savings target is not a forecast, and the moment those blend the number stops being useful.</a:t>
             </a:r>
-            <a:endParaRPr lang="en-US" dirty="0"/>
           </a:p>
         </p:txBody>
       </p:sp>
@@ -885,7 +691,6 @@
 Fourth, and only then, rephasing discretionary planned work with asset and service leads.
 And I'd be explicit about the second-order effect. Deferring planned work tends to increase responsive demand later, and moves spend that would have been capitalised into revenue. That lands on operating surplus, not just between years. Every action needs an owner, a date, a cost and an evidenced benefit.</a:t>
             </a:r>
-            <a:endParaRPr lang="en-US" dirty="0"/>
           </a:p>
         </p:txBody>
       </p:sp>
@@ -978,7 +783,6 @@
 Put those together and a repairs overspend touches operating surplus, interest cover and potentially the cost of borrowing. That is the frame I'd use, and why I'd want treasury in the conversation early.
 [Source] Codi Group regulatory judgement, published July 2026; reporting on Codi's £130m sustainability-linked facility.</a:t>
             </a:r>
-            <a:endParaRPr lang="en-US" dirty="0"/>
           </a:p>
         </p:txBody>
       </p:sp>
@@ -1070,7 +874,6 @@
 On service: WHQS hazard response compliance, first-time fix, jobs per operative to show whether insourced capacity is landing, backlog age and overdue safety work, and satisfaction or repeat contact. Those are the early warning that a saving is coming out of the resident rather than out of the cost.
 A number the operation recognises, a forecast that stops moving, and a resident who does not have to ring twice. Thank you, and I'm happy to take questions.</a:t>
             </a:r>
-            <a:endParaRPr lang="en-US" dirty="0"/>
           </a:p>
         </p:txBody>
       </p:sp>
@@ -1143,6 +946,11 @@
 <file path=ppt/slideMasters/slideMaster1.xml><?xml version="1.0" encoding="utf-8"?>
 <p:sldMaster xmlns:a="http://schemas.openxmlformats.org/drawingml/2006/main" xmlns:r="http://schemas.openxmlformats.org/officeDocument/2006/relationships" xmlns:p="http://schemas.openxmlformats.org/presentationml/2006/main">
   <p:cSld>
+    <p:bg>
+      <p:bgRef idx="1001">
+        <a:schemeClr val="bg1"/>
+      </p:bgRef>
+    </p:bg>
     <p:spTree>
       <p:nvGrpSpPr>
         <p:cNvPr id="1" name=""/>
@@ -1157,6 +965,54 @@
           <a:chExt cx="0" cy="0"/>
         </a:xfrm>
       </p:grpSpPr>
+      <p:sp>
+        <p:nvSpPr>
+          <p:cNvPr id="3" name="TextBox 2">
+            <a:extLst>
+              <a:ext uri="{FF2B5EF4-FFF2-40B4-BE49-F238E27FC236}">
+                <a16:creationId xmlns:a16="http://schemas.microsoft.com/office/drawing/2014/main" id="{4322D005-52EF-5A44-6380-0A6FDC5E0C3B}"/>
+              </a:ext>
+            </a:extLst>
+          </p:cNvPr>
+          <p:cNvSpPr txBox="1"/>
+          <p:nvPr userDrawn="1">
+            <p:extLst>
+              <p:ext uri="{1162E1C5-73C7-4A58-AE30-91384D911F3F}">
+                <p184:classification xmlns:p184="http://schemas.microsoft.com/office/powerpoint/2018/4/main" val="ftr"/>
+              </p:ext>
+            </p:extLst>
+          </p:nvPr>
+        </p:nvSpPr>
+        <p:spPr>
+          <a:xfrm>
+            <a:off x="5778500" y="6642100"/>
+            <a:ext cx="669925" cy="152400"/>
+          </a:xfrm>
+          <a:prstGeom prst="rect">
+            <a:avLst/>
+          </a:prstGeom>
+        </p:spPr>
+        <p:txBody>
+          <a:bodyPr horzOverflow="overflow" lIns="0" tIns="0" rIns="0" bIns="0">
+            <a:spAutoFit/>
+          </a:bodyPr>
+          <a:lstStyle/>
+          <a:p>
+            <a:pPr algn="l"/>
+            <a:r>
+              <a:rPr lang="en-GB" sz="1000">
+                <a:solidFill>
+                  <a:srgbClr val="000000">
+                    <a:alpha val="50000"/>
+                  </a:srgbClr>
+                </a:solidFill>
+                <a:latin typeface="Mylius Modern" panose="020B0504020202020204" pitchFamily="34" charset="0"/>
+              </a:rPr>
+              <a:t>INTERNAL</a:t>
+            </a:r>
+          </a:p>
+        </p:txBody>
+      </p:sp>
     </p:spTree>
   </p:cSld>
   <p:clrMap bg1="lt1" tx1="dk1" bg2="lt2" tx2="dk2" accent1="accent1" accent2="accent2" accent3="accent3" accent4="accent4" accent5="accent5" accent6="accent6" hlink="hlink" folHlink="folHlink"/>
@@ -1425,6 +1281,7 @@
         <a:solidFill>
           <a:srgbClr val="13453B"/>
         </a:solidFill>
+        <a:effectLst/>
       </p:bgPr>
     </p:bg>
     <p:spTree>
@@ -1462,11 +1319,11 @@
           <a:bodyPr wrap="square" lIns="0" tIns="0" rIns="0" bIns="0" rtlCol="0" anchor="ctr"/>
           <a:lstStyle/>
           <a:p>
-            <a:pPr indent="0" marL="0">
-              <a:buNone/>
-            </a:pPr>
-            <a:r>
-              <a:rPr lang="en-US" sz="1100" b="1" spc="240" kern="0" dirty="0">
+            <a:pPr marL="0" indent="0">
+              <a:buNone/>
+            </a:pPr>
+            <a:r>
+              <a:rPr lang="en-US" sz="1100" b="1" kern="0" spc="240" dirty="0">
                 <a:solidFill>
                   <a:srgbClr val="8FBFAE"/>
                 </a:solidFill>
@@ -1501,7 +1358,7 @@
           <a:bodyPr wrap="square" lIns="0" tIns="0" rIns="0" bIns="0" rtlCol="0" anchor="ctr"/>
           <a:lstStyle/>
           <a:p>
-            <a:pPr indent="0" marL="0">
+            <a:pPr marL="0" indent="0">
               <a:lnSpc>
                 <a:spcPts val="4600"/>
               </a:lnSpc>
@@ -1521,7 +1378,7 @@
             <a:endParaRPr lang="en-US" sz="4000" dirty="0"/>
           </a:p>
           <a:p>
-            <a:pPr indent="0" marL="0">
+            <a:pPr marL="0" indent="0">
               <a:lnSpc>
                 <a:spcPts val="4600"/>
               </a:lnSpc>
@@ -1539,45 +1396,6 @@
               <a:t>Across Repairs &amp; Maintenance</a:t>
             </a:r>
             <a:endParaRPr lang="en-US" sz="4000" dirty="0"/>
-          </a:p>
-        </p:txBody>
-      </p:sp>
-      <p:sp>
-        <p:nvSpPr>
-          <p:cNvPr id="4" name="Text 2"/>
-          <p:cNvSpPr txBox="1"/>
-          <p:nvPr/>
-        </p:nvSpPr>
-        <p:spPr>
-          <a:xfrm>
-            <a:off x="548640" y="3794760"/>
-            <a:ext cx="10607040" cy="411480"/>
-          </a:xfrm>
-          <a:prstGeom prst="rect">
-            <a:avLst/>
-          </a:prstGeom>
-          <a:noFill/>
-          <a:ln/>
-        </p:spPr>
-        <p:txBody>
-          <a:bodyPr wrap="square" lIns="0" tIns="0" rIns="0" bIns="0" rtlCol="0" anchor="ctr"/>
-          <a:lstStyle/>
-          <a:p>
-            <a:pPr indent="0" marL="0">
-              <a:buNone/>
-            </a:pPr>
-            <a:r>
-              <a:rPr lang="en-US" sz="1700" i="1" dirty="0">
-                <a:solidFill>
-                  <a:srgbClr val="C8892F"/>
-                </a:solidFill>
-                <a:latin typeface="Calibri" pitchFamily="34" charset="0"/>
-                <a:ea typeface="Calibri" pitchFamily="34" charset="-122"/>
-                <a:cs typeface="Calibri" pitchFamily="34" charset="-120"/>
-              </a:rPr>
-              <a:t>Size it.  Explain it.  Own it together.  Protect the home.</a:t>
-            </a:r>
-            <a:endParaRPr lang="en-US" sz="1700" dirty="0"/>
           </a:p>
         </p:txBody>
       </p:sp>
@@ -1603,6 +1421,13 @@
             <a:prstDash val="solid"/>
           </a:ln>
         </p:spPr>
+        <p:txBody>
+          <a:bodyPr/>
+          <a:lstStyle/>
+          <a:p>
+            <a:endParaRPr lang="en-GB"/>
+          </a:p>
+        </p:txBody>
       </p:sp>
       <p:sp>
         <p:nvSpPr>
@@ -1625,7 +1450,7 @@
           <a:bodyPr wrap="square" lIns="0" tIns="0" rIns="0" bIns="0" rtlCol="0" anchor="ctr"/>
           <a:lstStyle/>
           <a:p>
-            <a:pPr indent="0" marL="0">
+            <a:pPr marL="0" indent="0">
               <a:buNone/>
             </a:pPr>
             <a:r>
@@ -1664,7 +1489,7 @@
           <a:bodyPr wrap="square" lIns="0" tIns="0" rIns="0" bIns="0" rtlCol="0" anchor="ctr"/>
           <a:lstStyle/>
           <a:p>
-            <a:pPr indent="0" marL="0">
+            <a:pPr marL="0" indent="0">
               <a:buNone/>
             </a:pPr>
             <a:r>
@@ -1698,6 +1523,7 @@
         <a:solidFill>
           <a:srgbClr val="FFFFFF"/>
         </a:solidFill>
+        <a:effectLst/>
       </p:bgPr>
     </p:bg>
     <p:spTree>
@@ -1735,11 +1561,11 @@
           <a:bodyPr wrap="square" lIns="0" tIns="0" rIns="0" bIns="0" rtlCol="0" anchor="ctr"/>
           <a:lstStyle/>
           <a:p>
-            <a:pPr indent="0" marL="0">
-              <a:buNone/>
-            </a:pPr>
-            <a:r>
-              <a:rPr lang="en-US" sz="1000" b="1" spc="220" kern="0" dirty="0">
+            <a:pPr marL="0" indent="0">
+              <a:buNone/>
+            </a:pPr>
+            <a:r>
+              <a:rPr lang="en-US" sz="1000" b="1" kern="0" spc="220" dirty="0">
                 <a:solidFill>
                   <a:srgbClr val="C8892F"/>
                 </a:solidFill>
@@ -1761,7 +1587,7 @@
         </p:nvSpPr>
         <p:spPr>
           <a:xfrm>
-            <a:off x="548640" y="658368"/>
+            <a:off x="548640" y="612648"/>
             <a:ext cx="11094415" cy="566928"/>
           </a:xfrm>
           <a:prstGeom prst="rect">
@@ -1774,7 +1600,7 @@
           <a:bodyPr wrap="square" lIns="0" tIns="0" rIns="0" bIns="0" rtlCol="0" anchor="ctr"/>
           <a:lstStyle/>
           <a:p>
-            <a:pPr indent="0" marL="0">
+            <a:pPr marL="0" indent="0">
               <a:buNone/>
             </a:pPr>
             <a:r>
@@ -1786,7 +1612,7 @@
                 <a:ea typeface="Cambria" pitchFamily="34" charset="-122"/>
                 <a:cs typeface="Cambria" pitchFamily="34" charset="-120"/>
               </a:rPr>
-              <a:t>Scope the number before you explain it</a:t>
+              <a:t>Scope the number</a:t>
             </a:r>
             <a:endParaRPr lang="en-US" sz="3000" dirty="0"/>
           </a:p>
@@ -1818,6 +1644,13 @@
             <a:prstDash val="solid"/>
           </a:ln>
         </p:spPr>
+        <p:txBody>
+          <a:bodyPr/>
+          <a:lstStyle/>
+          <a:p>
+            <a:endParaRPr lang="en-GB"/>
+          </a:p>
+        </p:txBody>
       </p:sp>
       <p:sp>
         <p:nvSpPr>
@@ -1840,7 +1673,7 @@
           <a:bodyPr wrap="square" lIns="0" tIns="0" rIns="0" bIns="0" rtlCol="0" anchor="ctr"/>
           <a:lstStyle/>
           <a:p>
-            <a:pPr indent="0" marL="0">
+            <a:pPr marL="0" indent="0">
               <a:buNone/>
             </a:pPr>
             <a:r>
@@ -1879,7 +1712,7 @@
           <a:bodyPr wrap="square" lIns="0" tIns="0" rIns="0" bIns="0" rtlCol="0" anchor="ctr"/>
           <a:lstStyle/>
           <a:p>
-            <a:pPr indent="0" marL="0">
+            <a:pPr marL="0" indent="0">
               <a:buNone/>
             </a:pPr>
             <a:r>
@@ -1918,7 +1751,7 @@
           <a:bodyPr wrap="square" lIns="0" tIns="0" rIns="0" bIns="0" rtlCol="0" anchor="ctr"/>
           <a:lstStyle/>
           <a:p>
-            <a:pPr indent="0" marL="0">
+            <a:pPr marL="0" indent="0">
               <a:buNone/>
             </a:pPr>
             <a:r>
@@ -1945,7 +1778,7 @@
         <p:spPr>
           <a:xfrm>
             <a:off x="548640" y="3931920"/>
-            <a:ext cx="4114800" cy="914400"/>
+            <a:ext cx="4114800" cy="1033272"/>
           </a:xfrm>
           <a:prstGeom prst="rect">
             <a:avLst/>
@@ -1957,7 +1790,7 @@
           <a:bodyPr wrap="square" lIns="0" tIns="0" rIns="0" bIns="0" rtlCol="0" anchor="t"/>
           <a:lstStyle/>
           <a:p>
-            <a:pPr indent="0" marL="0">
+            <a:pPr marL="0" indent="0">
               <a:lnSpc>
                 <a:spcPts val="1900"/>
               </a:lnSpc>
@@ -1972,7 +1805,7 @@
                 <a:ea typeface="Calibri" pitchFamily="34" charset="-122"/>
                 <a:cs typeface="Calibri" pitchFamily="34" charset="-120"/>
               </a:rPr>
-              <a:t>At that level this is not a responsive repairs budget. It spans several services with different cost behaviours — and it straddles the revenue and capital boundary.</a:t>
+              <a:t>At that level this is not only a responsive repairs budget. It spans several services with different cost behaviours — and it straddles both Revenue (operational expenditure) and Capital.</a:t>
             </a:r>
             <a:endParaRPr lang="en-US" sz="1300" dirty="0"/>
           </a:p>
@@ -1980,18 +1813,18 @@
       </p:sp>
       <p:sp>
         <p:nvSpPr>
-          <p:cNvPr id="9" name="Shape 7"/>
+          <p:cNvPr id="11" name="Shape 9"/>
           <p:cNvSpPr/>
           <p:nvPr/>
         </p:nvSpPr>
         <p:spPr>
           <a:xfrm>
-            <a:off x="548640" y="4937760"/>
-            <a:ext cx="4114800" cy="1170432"/>
+            <a:off x="5029200" y="1600200"/>
+            <a:ext cx="6611112" cy="1024128"/>
           </a:xfrm>
           <a:prstGeom prst="roundRect">
             <a:avLst>
-              <a:gd name="adj" fmla="val 4688"/>
+              <a:gd name="adj" fmla="val 5357"/>
             </a:avLst>
           </a:prstGeom>
           <a:solidFill>
@@ -2004,75 +1837,140 @@
             <a:prstDash val="solid"/>
           </a:ln>
         </p:spPr>
-      </p:sp>
-      <p:sp>
-        <p:nvSpPr>
-          <p:cNvPr id="10" name="Text 8"/>
-          <p:cNvSpPr txBox="1"/>
-          <p:nvPr/>
-        </p:nvSpPr>
-        <p:spPr>
-          <a:xfrm>
-            <a:off x="804672" y="4937760"/>
-            <a:ext cx="3602736" cy="1170432"/>
-          </a:xfrm>
-          <a:prstGeom prst="rect">
-            <a:avLst/>
-          </a:prstGeom>
-          <a:noFill/>
-          <a:ln/>
-        </p:spPr>
-        <p:txBody>
-          <a:bodyPr wrap="square" lIns="0" tIns="0" rIns="0" bIns="0" rtlCol="0" anchor="ctr"/>
-          <a:lstStyle/>
-          <a:p>
-            <a:pPr indent="0" marL="0">
-              <a:lnSpc>
-                <a:spcPts val="1700"/>
-              </a:lnSpc>
-              <a:buNone/>
-            </a:pPr>
-            <a:r>
-              <a:rPr lang="en-US" sz="1200" b="1" dirty="0">
-                <a:solidFill>
-                  <a:srgbClr val="13453B"/>
-                </a:solidFill>
-                <a:latin typeface="Calibri" pitchFamily="34" charset="0"/>
-                <a:ea typeface="Calibri" pitchFamily="34" charset="-122"/>
-                <a:cs typeface="Calibri" pitchFamily="34" charset="-120"/>
-              </a:rPr>
-              <a:t>First question I'd ask.  </a:t>
-            </a:r>
-            <a:pPr indent="0" marL="0">
-              <a:lnSpc>
-                <a:spcPts val="1700"/>
-              </a:lnSpc>
-              <a:buNone/>
-            </a:pPr>
-            <a:r>
-              <a:rPr lang="en-US" sz="1200" dirty="0">
-                <a:solidFill>
-                  <a:srgbClr val="33423D"/>
-                </a:solidFill>
-                <a:latin typeface="Calibri" pitchFamily="34" charset="0"/>
-                <a:ea typeface="Calibri" pitchFamily="34" charset="-122"/>
-                <a:cs typeface="Calibri" pitchFamily="34" charset="-120"/>
-              </a:rPr>
-              <a:t>Where is the revenue/capital line drawn — and is it applied the same way across both legacy policies?</a:t>
-            </a:r>
-            <a:endParaRPr lang="en-US" sz="1200" dirty="0"/>
-          </a:p>
-        </p:txBody>
-      </p:sp>
-      <p:sp>
-        <p:nvSpPr>
-          <p:cNvPr id="11" name="Shape 9"/>
+        <p:txBody>
+          <a:bodyPr/>
+          <a:lstStyle/>
+          <a:p>
+            <a:endParaRPr lang="en-GB"/>
+          </a:p>
+        </p:txBody>
+      </p:sp>
+      <p:sp>
+        <p:nvSpPr>
+          <p:cNvPr id="12" name="Text 10"/>
+          <p:cNvSpPr txBox="1"/>
+          <p:nvPr/>
+        </p:nvSpPr>
+        <p:spPr>
+          <a:xfrm>
+            <a:off x="5303520" y="1746504"/>
+            <a:ext cx="4206240" cy="292608"/>
+          </a:xfrm>
+          <a:prstGeom prst="rect">
+            <a:avLst/>
+          </a:prstGeom>
+          <a:noFill/>
+          <a:ln/>
+        </p:spPr>
+        <p:txBody>
+          <a:bodyPr wrap="square" lIns="0" tIns="0" rIns="0" bIns="0" rtlCol="0" anchor="ctr"/>
+          <a:lstStyle/>
+          <a:p>
+            <a:pPr marL="0" indent="0">
+              <a:buNone/>
+            </a:pPr>
+            <a:r>
+              <a:rPr lang="en-US" sz="1400" b="1" dirty="0">
+                <a:solidFill>
+                  <a:srgbClr val="16211E"/>
+                </a:solidFill>
+                <a:latin typeface="Calibri" pitchFamily="34" charset="0"/>
+                <a:ea typeface="Calibri" pitchFamily="34" charset="-122"/>
+                <a:cs typeface="Calibri" pitchFamily="34" charset="-120"/>
+              </a:rPr>
+              <a:t>Responsive / reactive repairs</a:t>
+            </a:r>
+            <a:endParaRPr lang="en-US" sz="1400" dirty="0"/>
+          </a:p>
+        </p:txBody>
+      </p:sp>
+      <p:sp>
+        <p:nvSpPr>
+          <p:cNvPr id="13" name="Text 11"/>
+          <p:cNvSpPr txBox="1"/>
+          <p:nvPr/>
+        </p:nvSpPr>
+        <p:spPr>
+          <a:xfrm>
+            <a:off x="5303520" y="2075688"/>
+            <a:ext cx="4754880" cy="365760"/>
+          </a:xfrm>
+          <a:prstGeom prst="rect">
+            <a:avLst/>
+          </a:prstGeom>
+          <a:noFill/>
+          <a:ln/>
+        </p:spPr>
+        <p:txBody>
+          <a:bodyPr wrap="square" lIns="0" tIns="0" rIns="0" bIns="0" rtlCol="0" anchor="ctr"/>
+          <a:lstStyle/>
+          <a:p>
+            <a:pPr marL="0" indent="0">
+              <a:buNone/>
+            </a:pPr>
+            <a:r>
+              <a:rPr lang="en-US" sz="1150" dirty="0">
+                <a:solidFill>
+                  <a:srgbClr val="6E7D78"/>
+                </a:solidFill>
+                <a:latin typeface="Calibri" pitchFamily="34" charset="0"/>
+                <a:ea typeface="Calibri" pitchFamily="34" charset="-122"/>
+                <a:cs typeface="Calibri" pitchFamily="34" charset="-120"/>
+              </a:rPr>
+              <a:t>Demand-led, volatile, difficult to forecast</a:t>
+            </a:r>
+            <a:endParaRPr lang="en-US" sz="1150" dirty="0"/>
+          </a:p>
+        </p:txBody>
+      </p:sp>
+      <p:sp>
+        <p:nvSpPr>
+          <p:cNvPr id="14" name="Text 12"/>
+          <p:cNvSpPr txBox="1"/>
+          <p:nvPr/>
+        </p:nvSpPr>
+        <p:spPr>
+          <a:xfrm>
+            <a:off x="9966960" y="1746504"/>
+            <a:ext cx="1463040" cy="274320"/>
+          </a:xfrm>
+          <a:prstGeom prst="rect">
+            <a:avLst/>
+          </a:prstGeom>
+          <a:noFill/>
+          <a:ln/>
+        </p:spPr>
+        <p:txBody>
+          <a:bodyPr wrap="square" lIns="0" tIns="0" rIns="0" bIns="0" rtlCol="0" anchor="ctr"/>
+          <a:lstStyle/>
+          <a:p>
+            <a:pPr marL="0" indent="0" algn="r">
+              <a:buNone/>
+            </a:pPr>
+            <a:r>
+              <a:rPr lang="en-US" sz="1050" b="1" dirty="0">
+                <a:solidFill>
+                  <a:srgbClr val="2E7D68"/>
+                </a:solidFill>
+                <a:latin typeface="Calibri" pitchFamily="34" charset="0"/>
+                <a:ea typeface="Calibri" pitchFamily="34" charset="-122"/>
+                <a:cs typeface="Calibri" pitchFamily="34" charset="-120"/>
+              </a:rPr>
+              <a:t>Revenue</a:t>
+            </a:r>
+            <a:endParaRPr lang="en-US" sz="1050" dirty="0"/>
+          </a:p>
+        </p:txBody>
+      </p:sp>
+      <p:sp>
+        <p:nvSpPr>
+          <p:cNvPr id="15" name="Shape 13"/>
           <p:cNvSpPr/>
           <p:nvPr/>
         </p:nvSpPr>
         <p:spPr>
           <a:xfrm>
-            <a:off x="5029200" y="1600200"/>
+            <a:off x="5029200" y="2762374"/>
             <a:ext cx="6611112" cy="1024128"/>
           </a:xfrm>
           <a:prstGeom prst="roundRect">
@@ -2090,16 +1988,23 @@
             <a:prstDash val="solid"/>
           </a:ln>
         </p:spPr>
-      </p:sp>
-      <p:sp>
-        <p:nvSpPr>
-          <p:cNvPr id="12" name="Text 10"/>
-          <p:cNvSpPr txBox="1"/>
-          <p:nvPr/>
-        </p:nvSpPr>
-        <p:spPr>
-          <a:xfrm>
-            <a:off x="5303520" y="1746504"/>
+        <p:txBody>
+          <a:bodyPr/>
+          <a:lstStyle/>
+          <a:p>
+            <a:endParaRPr lang="en-GB"/>
+          </a:p>
+        </p:txBody>
+      </p:sp>
+      <p:sp>
+        <p:nvSpPr>
+          <p:cNvPr id="16" name="Text 14"/>
+          <p:cNvSpPr txBox="1"/>
+          <p:nvPr/>
+        </p:nvSpPr>
+        <p:spPr>
+          <a:xfrm>
+            <a:off x="5303520" y="2916936"/>
             <a:ext cx="4206240" cy="292608"/>
           </a:xfrm>
           <a:prstGeom prst="rect">
@@ -2112,7 +2017,7 @@
           <a:bodyPr wrap="square" lIns="0" tIns="0" rIns="0" bIns="0" rtlCol="0" anchor="ctr"/>
           <a:lstStyle/>
           <a:p>
-            <a:pPr indent="0" marL="0">
+            <a:pPr marL="0" indent="0">
               <a:buNone/>
             </a:pPr>
             <a:r>
@@ -2124,7 +2029,7 @@
                 <a:ea typeface="Calibri" pitchFamily="34" charset="-122"/>
                 <a:cs typeface="Calibri" pitchFamily="34" charset="-120"/>
               </a:rPr>
-              <a:t>Responsive repairs &amp; voids</a:t>
+              <a:t>Cyclical</a:t>
             </a:r>
             <a:endParaRPr lang="en-US" sz="1400" dirty="0"/>
           </a:p>
@@ -2132,13 +2037,13 @@
       </p:sp>
       <p:sp>
         <p:nvSpPr>
-          <p:cNvPr id="13" name="Text 11"/>
-          <p:cNvSpPr txBox="1"/>
-          <p:nvPr/>
-        </p:nvSpPr>
-        <p:spPr>
-          <a:xfrm>
-            <a:off x="5303520" y="2075688"/>
+          <p:cNvPr id="17" name="Text 15"/>
+          <p:cNvSpPr txBox="1"/>
+          <p:nvPr/>
+        </p:nvSpPr>
+        <p:spPr>
+          <a:xfrm>
+            <a:off x="5303520" y="3246120"/>
             <a:ext cx="4754880" cy="365760"/>
           </a:xfrm>
           <a:prstGeom prst="rect">
@@ -2151,7 +2056,7 @@
           <a:bodyPr wrap="square" lIns="0" tIns="0" rIns="0" bIns="0" rtlCol="0" anchor="ctr"/>
           <a:lstStyle/>
           <a:p>
-            <a:pPr indent="0" marL="0">
+            <a:pPr marL="0" indent="0">
               <a:buNone/>
             </a:pPr>
             <a:r>
@@ -2163,7 +2068,7 @@
                 <a:ea typeface="Calibri" pitchFamily="34" charset="-122"/>
                 <a:cs typeface="Calibri" pitchFamily="34" charset="-120"/>
               </a:rPr>
-              <a:t>Demand-led, volatile, hardest to forecast</a:t>
+              <a:t>Servicing, decoration – predictable</a:t>
             </a:r>
             <a:endParaRPr lang="en-US" sz="1150" dirty="0"/>
           </a:p>
@@ -2171,13 +2076,13 @@
       </p:sp>
       <p:sp>
         <p:nvSpPr>
-          <p:cNvPr id="14" name="Text 12"/>
-          <p:cNvSpPr txBox="1"/>
-          <p:nvPr/>
-        </p:nvSpPr>
-        <p:spPr>
-          <a:xfrm>
-            <a:off x="9966960" y="1746504"/>
+          <p:cNvPr id="18" name="Text 16"/>
+          <p:cNvSpPr txBox="1"/>
+          <p:nvPr/>
+        </p:nvSpPr>
+        <p:spPr>
+          <a:xfrm>
+            <a:off x="10009918" y="2909293"/>
             <a:ext cx="1463040" cy="274320"/>
           </a:xfrm>
           <a:prstGeom prst="rect">
@@ -2190,7 +2095,7 @@
           <a:bodyPr wrap="square" lIns="0" tIns="0" rIns="0" bIns="0" rtlCol="0" anchor="ctr"/>
           <a:lstStyle/>
           <a:p>
-            <a:pPr algn="r" indent="0" marL="0">
+            <a:pPr marL="0" indent="0" algn="r">
               <a:buNone/>
             </a:pPr>
             <a:r>
@@ -2210,13 +2115,13 @@
       </p:sp>
       <p:sp>
         <p:nvSpPr>
-          <p:cNvPr id="15" name="Shape 13"/>
+          <p:cNvPr id="19" name="Shape 17"/>
           <p:cNvSpPr/>
           <p:nvPr/>
         </p:nvSpPr>
         <p:spPr>
           <a:xfrm>
-            <a:off x="5029200" y="2770632"/>
+            <a:off x="5029200" y="5404104"/>
             <a:ext cx="6611112" cy="1024128"/>
           </a:xfrm>
           <a:prstGeom prst="roundRect">
@@ -2234,16 +2139,23 @@
             <a:prstDash val="solid"/>
           </a:ln>
         </p:spPr>
-      </p:sp>
-      <p:sp>
-        <p:nvSpPr>
-          <p:cNvPr id="16" name="Text 14"/>
-          <p:cNvSpPr txBox="1"/>
-          <p:nvPr/>
-        </p:nvSpPr>
-        <p:spPr>
-          <a:xfrm>
-            <a:off x="5303520" y="2916936"/>
+        <p:txBody>
+          <a:bodyPr/>
+          <a:lstStyle/>
+          <a:p>
+            <a:endParaRPr lang="en-GB"/>
+          </a:p>
+        </p:txBody>
+      </p:sp>
+      <p:sp>
+        <p:nvSpPr>
+          <p:cNvPr id="20" name="Text 18"/>
+          <p:cNvSpPr txBox="1"/>
+          <p:nvPr/>
+        </p:nvSpPr>
+        <p:spPr>
+          <a:xfrm>
+            <a:off x="5303520" y="5545372"/>
             <a:ext cx="4206240" cy="292608"/>
           </a:xfrm>
           <a:prstGeom prst="rect">
@@ -2256,7 +2168,7 @@
           <a:bodyPr wrap="square" lIns="0" tIns="0" rIns="0" bIns="0" rtlCol="0" anchor="ctr"/>
           <a:lstStyle/>
           <a:p>
-            <a:pPr indent="0" marL="0">
+            <a:pPr marL="0" indent="0">
               <a:buNone/>
             </a:pPr>
             <a:r>
@@ -2268,7 +2180,7 @@
                 <a:ea typeface="Calibri" pitchFamily="34" charset="-122"/>
                 <a:cs typeface="Calibri" pitchFamily="34" charset="-120"/>
               </a:rPr>
-              <a:t>Cyclical &amp; compliance</a:t>
+              <a:t>Planned &amp; major works</a:t>
             </a:r>
             <a:endParaRPr lang="en-US" sz="1400" dirty="0"/>
           </a:p>
@@ -2276,13 +2188,13 @@
       </p:sp>
       <p:sp>
         <p:nvSpPr>
-          <p:cNvPr id="17" name="Text 15"/>
-          <p:cNvSpPr txBox="1"/>
-          <p:nvPr/>
-        </p:nvSpPr>
-        <p:spPr>
-          <a:xfrm>
-            <a:off x="5303520" y="3246120"/>
+          <p:cNvPr id="21" name="Text 19"/>
+          <p:cNvSpPr txBox="1"/>
+          <p:nvPr/>
+        </p:nvSpPr>
+        <p:spPr>
+          <a:xfrm>
+            <a:off x="5303520" y="5954397"/>
             <a:ext cx="4754880" cy="365760"/>
           </a:xfrm>
           <a:prstGeom prst="rect">
@@ -2295,7 +2207,7 @@
           <a:bodyPr wrap="square" lIns="0" tIns="0" rIns="0" bIns="0" rtlCol="0" anchor="ctr"/>
           <a:lstStyle/>
           <a:p>
-            <a:pPr indent="0" marL="0">
+            <a:pPr marL="0" indent="0">
               <a:buNone/>
             </a:pPr>
             <a:r>
@@ -2307,7 +2219,7 @@
                 <a:ea typeface="Calibri" pitchFamily="34" charset="-122"/>
                 <a:cs typeface="Calibri" pitchFamily="34" charset="-120"/>
               </a:rPr>
-              <a:t>Servicing and the big six — protected spend</a:t>
+              <a:t>Component replacement, WHQS, retrofit</a:t>
             </a:r>
             <a:endParaRPr lang="en-US" sz="1150" dirty="0"/>
           </a:p>
@@ -2315,13 +2227,13 @@
       </p:sp>
       <p:sp>
         <p:nvSpPr>
-          <p:cNvPr id="18" name="Text 16"/>
-          <p:cNvSpPr txBox="1"/>
-          <p:nvPr/>
-        </p:nvSpPr>
-        <p:spPr>
-          <a:xfrm>
-            <a:off x="9966960" y="2916936"/>
+          <p:cNvPr id="22" name="Text 20"/>
+          <p:cNvSpPr txBox="1"/>
+          <p:nvPr/>
+        </p:nvSpPr>
+        <p:spPr>
+          <a:xfrm>
+            <a:off x="10058400" y="5467867"/>
             <a:ext cx="1463040" cy="274320"/>
           </a:xfrm>
           <a:prstGeom prst="rect">
@@ -2334,257 +2246,21 @@
           <a:bodyPr wrap="square" lIns="0" tIns="0" rIns="0" bIns="0" rtlCol="0" anchor="ctr"/>
           <a:lstStyle/>
           <a:p>
-            <a:pPr algn="r" indent="0" marL="0">
+            <a:pPr marL="0" indent="0" algn="r">
               <a:buNone/>
             </a:pPr>
             <a:r>
               <a:rPr lang="en-US" sz="1050" b="1" dirty="0">
                 <a:solidFill>
-                  <a:srgbClr val="2E7D68"/>
-                </a:solidFill>
-                <a:latin typeface="Calibri" pitchFamily="34" charset="0"/>
-                <a:ea typeface="Calibri" pitchFamily="34" charset="-122"/>
-                <a:cs typeface="Calibri" pitchFamily="34" charset="-120"/>
-              </a:rPr>
-              <a:t>Revenue</a:t>
+                  <a:srgbClr val="C8892F"/>
+                </a:solidFill>
+                <a:latin typeface="Calibri" pitchFamily="34" charset="0"/>
+                <a:ea typeface="Calibri" pitchFamily="34" charset="-122"/>
+                <a:cs typeface="Calibri" pitchFamily="34" charset="-120"/>
+              </a:rPr>
+              <a:t>Largely capital</a:t>
             </a:r>
             <a:endParaRPr lang="en-US" sz="1050" dirty="0"/>
-          </a:p>
-        </p:txBody>
-      </p:sp>
-      <p:sp>
-        <p:nvSpPr>
-          <p:cNvPr id="19" name="Shape 17"/>
-          <p:cNvSpPr/>
-          <p:nvPr/>
-        </p:nvSpPr>
-        <p:spPr>
-          <a:xfrm>
-            <a:off x="5029200" y="3941064"/>
-            <a:ext cx="6611112" cy="1024128"/>
-          </a:xfrm>
-          <a:prstGeom prst="roundRect">
-            <a:avLst>
-              <a:gd name="adj" fmla="val 5357"/>
-            </a:avLst>
-          </a:prstGeom>
-          <a:solidFill>
-            <a:srgbClr val="F1F5F3"/>
-          </a:solidFill>
-          <a:ln w="12700">
-            <a:solidFill>
-              <a:srgbClr val="F1F5F3"/>
-            </a:solidFill>
-            <a:prstDash val="solid"/>
-          </a:ln>
-        </p:spPr>
-      </p:sp>
-      <p:sp>
-        <p:nvSpPr>
-          <p:cNvPr id="20" name="Text 18"/>
-          <p:cNvSpPr txBox="1"/>
-          <p:nvPr/>
-        </p:nvSpPr>
-        <p:spPr>
-          <a:xfrm>
-            <a:off x="5303520" y="4087368"/>
-            <a:ext cx="4206240" cy="292608"/>
-          </a:xfrm>
-          <a:prstGeom prst="rect">
-            <a:avLst/>
-          </a:prstGeom>
-          <a:noFill/>
-          <a:ln/>
-        </p:spPr>
-        <p:txBody>
-          <a:bodyPr wrap="square" lIns="0" tIns="0" rIns="0" bIns="0" rtlCol="0" anchor="ctr"/>
-          <a:lstStyle/>
-          <a:p>
-            <a:pPr indent="0" marL="0">
-              <a:buNone/>
-            </a:pPr>
-            <a:r>
-              <a:rPr lang="en-US" sz="1400" b="1" dirty="0">
-                <a:solidFill>
-                  <a:srgbClr val="16211E"/>
-                </a:solidFill>
-                <a:latin typeface="Calibri" pitchFamily="34" charset="0"/>
-                <a:ea typeface="Calibri" pitchFamily="34" charset="-122"/>
-                <a:cs typeface="Calibri" pitchFamily="34" charset="-120"/>
-              </a:rPr>
-              <a:t>Planned &amp; major works</a:t>
-            </a:r>
-            <a:endParaRPr lang="en-US" sz="1400" dirty="0"/>
-          </a:p>
-        </p:txBody>
-      </p:sp>
-      <p:sp>
-        <p:nvSpPr>
-          <p:cNvPr id="21" name="Text 19"/>
-          <p:cNvSpPr txBox="1"/>
-          <p:nvPr/>
-        </p:nvSpPr>
-        <p:spPr>
-          <a:xfrm>
-            <a:off x="5303520" y="4416552"/>
-            <a:ext cx="4754880" cy="365760"/>
-          </a:xfrm>
-          <a:prstGeom prst="rect">
-            <a:avLst/>
-          </a:prstGeom>
-          <a:noFill/>
-          <a:ln/>
-        </p:spPr>
-        <p:txBody>
-          <a:bodyPr wrap="square" lIns="0" tIns="0" rIns="0" bIns="0" rtlCol="0" anchor="ctr"/>
-          <a:lstStyle/>
-          <a:p>
-            <a:pPr indent="0" marL="0">
-              <a:buNone/>
-            </a:pPr>
-            <a:r>
-              <a:rPr lang="en-US" sz="1150" dirty="0">
-                <a:solidFill>
-                  <a:srgbClr val="6E7D78"/>
-                </a:solidFill>
-                <a:latin typeface="Calibri" pitchFamily="34" charset="0"/>
-                <a:ea typeface="Calibri" pitchFamily="34" charset="-122"/>
-                <a:cs typeface="Calibri" pitchFamily="34" charset="-120"/>
-              </a:rPr>
-              <a:t>Component replacement, WHQS, retrofit</a:t>
-            </a:r>
-            <a:endParaRPr lang="en-US" sz="1150" dirty="0"/>
-          </a:p>
-        </p:txBody>
-      </p:sp>
-      <p:sp>
-        <p:nvSpPr>
-          <p:cNvPr id="22" name="Text 20"/>
-          <p:cNvSpPr txBox="1"/>
-          <p:nvPr/>
-        </p:nvSpPr>
-        <p:spPr>
-          <a:xfrm>
-            <a:off x="9966960" y="4087368"/>
-            <a:ext cx="1463040" cy="274320"/>
-          </a:xfrm>
-          <a:prstGeom prst="rect">
-            <a:avLst/>
-          </a:prstGeom>
-          <a:noFill/>
-          <a:ln/>
-        </p:spPr>
-        <p:txBody>
-          <a:bodyPr wrap="square" lIns="0" tIns="0" rIns="0" bIns="0" rtlCol="0" anchor="ctr"/>
-          <a:lstStyle/>
-          <a:p>
-            <a:pPr algn="r" indent="0" marL="0">
-              <a:buNone/>
-            </a:pPr>
-            <a:r>
-              <a:rPr lang="en-US" sz="1050" b="1" dirty="0">
-                <a:solidFill>
-                  <a:srgbClr val="C8892F"/>
-                </a:solidFill>
-                <a:latin typeface="Calibri" pitchFamily="34" charset="0"/>
-                <a:ea typeface="Calibri" pitchFamily="34" charset="-122"/>
-                <a:cs typeface="Calibri" pitchFamily="34" charset="-120"/>
-              </a:rPr>
-              <a:t>Largely capital</a:t>
-            </a:r>
-            <a:endParaRPr lang="en-US" sz="1050" dirty="0"/>
-          </a:p>
-        </p:txBody>
-      </p:sp>
-      <p:sp>
-        <p:nvSpPr>
-          <p:cNvPr id="23" name="Text 21"/>
-          <p:cNvSpPr txBox="1"/>
-          <p:nvPr/>
-        </p:nvSpPr>
-        <p:spPr>
-          <a:xfrm>
-            <a:off x="5029200" y="5166360"/>
-            <a:ext cx="6611112" cy="411480"/>
-          </a:xfrm>
-          <a:prstGeom prst="rect">
-            <a:avLst/>
-          </a:prstGeom>
-          <a:noFill/>
-          <a:ln/>
-        </p:spPr>
-        <p:txBody>
-          <a:bodyPr wrap="square" lIns="0" tIns="0" rIns="0" bIns="0" rtlCol="0" anchor="ctr"/>
-          <a:lstStyle/>
-          <a:p>
-            <a:pPr indent="0" marL="0">
-              <a:buNone/>
-            </a:pPr>
-            <a:r>
-              <a:rPr lang="en-US" sz="1350" b="1" dirty="0">
-                <a:solidFill>
-                  <a:srgbClr val="16211E"/>
-                </a:solidFill>
-                <a:latin typeface="Calibri" pitchFamily="34" charset="0"/>
-                <a:ea typeface="Calibri" pitchFamily="34" charset="-122"/>
-                <a:cs typeface="Calibri" pitchFamily="34" charset="-120"/>
-              </a:rPr>
-              <a:t>One budget, three very different cost behaviours. </a:t>
-            </a:r>
-            <a:pPr indent="0" marL="0">
-              <a:buNone/>
-            </a:pPr>
-            <a:r>
-              <a:rPr lang="en-US" sz="1350" dirty="0">
-                <a:solidFill>
-                  <a:srgbClr val="33423D"/>
-                </a:solidFill>
-                <a:latin typeface="Calibri" pitchFamily="34" charset="0"/>
-                <a:ea typeface="Calibri" pitchFamily="34" charset="-122"/>
-                <a:cs typeface="Calibri" pitchFamily="34" charset="-120"/>
-              </a:rPr>
-              <a:t>You cannot forecast the total — you forecast the drivers underneath it.</a:t>
-            </a:r>
-            <a:endParaRPr lang="en-US" sz="1350" dirty="0"/>
-          </a:p>
-        </p:txBody>
-      </p:sp>
-      <p:sp>
-        <p:nvSpPr>
-          <p:cNvPr id="24" name="Text 22"/>
-          <p:cNvSpPr txBox="1"/>
-          <p:nvPr/>
-        </p:nvSpPr>
-        <p:spPr>
-          <a:xfrm>
-            <a:off x="5029200" y="5669280"/>
-            <a:ext cx="6611112" cy="274320"/>
-          </a:xfrm>
-          <a:prstGeom prst="rect">
-            <a:avLst/>
-          </a:prstGeom>
-          <a:noFill/>
-          <a:ln/>
-        </p:spPr>
-        <p:txBody>
-          <a:bodyPr wrap="square" lIns="0" tIns="0" rIns="0" bIns="0" rtlCol="0" anchor="ctr"/>
-          <a:lstStyle/>
-          <a:p>
-            <a:pPr indent="0" marL="0">
-              <a:buNone/>
-            </a:pPr>
-            <a:r>
-              <a:rPr lang="en-US" sz="1000" i="1" dirty="0">
-                <a:solidFill>
-                  <a:srgbClr val="6E7D78"/>
-                </a:solidFill>
-                <a:latin typeface="Calibri" pitchFamily="34" charset="0"/>
-                <a:ea typeface="Calibri" pitchFamily="34" charset="-122"/>
-                <a:cs typeface="Calibri" pitchFamily="34" charset="-120"/>
-              </a:rPr>
-              <a:t>Illustrative categories, to show how I would cut the budget — not Codi's actual structure.</a:t>
-            </a:r>
-            <a:endParaRPr lang="en-US" sz="1000" dirty="0"/>
           </a:p>
         </p:txBody>
       </p:sp>
@@ -2609,7 +2285,7 @@
           <a:bodyPr wrap="square" lIns="0" tIns="0" rIns="0" bIns="0" rtlCol="0" anchor="ctr"/>
           <a:lstStyle/>
           <a:p>
-            <a:pPr algn="l" indent="0" marL="0">
+            <a:pPr marL="0" indent="0" algn="l">
               <a:buNone/>
             </a:pPr>
             <a:r>
@@ -2648,7 +2324,7 @@
           <a:bodyPr wrap="square" lIns="0" tIns="0" rIns="0" bIns="0" rtlCol="0" anchor="ctr"/>
           <a:lstStyle/>
           <a:p>
-            <a:pPr algn="r" indent="0" marL="0">
+            <a:pPr marL="0" indent="0" algn="r">
               <a:buNone/>
             </a:pPr>
             <a:r>
@@ -2663,6 +2339,178 @@
               <a:t>2</a:t>
             </a:r>
             <a:endParaRPr lang="en-US" sz="900" dirty="0"/>
+          </a:p>
+        </p:txBody>
+      </p:sp>
+      <p:pic>
+        <p:nvPicPr>
+          <p:cNvPr id="28" name="Picture 27">
+            <a:extLst>
+              <a:ext uri="{FF2B5EF4-FFF2-40B4-BE49-F238E27FC236}">
+                <a16:creationId xmlns:a16="http://schemas.microsoft.com/office/drawing/2014/main" id="{91873581-5BEA-A6D0-06D1-E24C0FDDC8D0}"/>
+              </a:ext>
+            </a:extLst>
+          </p:cNvPr>
+          <p:cNvPicPr>
+            <a:picLocks noChangeAspect="1"/>
+          </p:cNvPicPr>
+          <p:nvPr/>
+        </p:nvPicPr>
+        <p:blipFill>
+          <a:blip r:embed="rId3"/>
+          <a:stretch>
+            <a:fillRect/>
+          </a:stretch>
+        </p:blipFill>
+        <p:spPr>
+          <a:xfrm>
+            <a:off x="5031674" y="4001474"/>
+            <a:ext cx="6626926" cy="1036410"/>
+          </a:xfrm>
+          <a:prstGeom prst="rect">
+            <a:avLst/>
+          </a:prstGeom>
+        </p:spPr>
+      </p:pic>
+      <p:sp>
+        <p:nvSpPr>
+          <p:cNvPr id="30" name="TextBox 29">
+            <a:extLst>
+              <a:ext uri="{FF2B5EF4-FFF2-40B4-BE49-F238E27FC236}">
+                <a16:creationId xmlns:a16="http://schemas.microsoft.com/office/drawing/2014/main" id="{DC4C8514-6341-1D8D-594B-9017E794FA69}"/>
+              </a:ext>
+            </a:extLst>
+          </p:cNvPr>
+          <p:cNvSpPr txBox="1"/>
+          <p:nvPr/>
+        </p:nvSpPr>
+        <p:spPr>
+          <a:xfrm>
+            <a:off x="5178020" y="4111824"/>
+            <a:ext cx="6097022" cy="307777"/>
+          </a:xfrm>
+          <a:prstGeom prst="rect">
+            <a:avLst/>
+          </a:prstGeom>
+          <a:noFill/>
+        </p:spPr>
+        <p:txBody>
+          <a:bodyPr wrap="square">
+            <a:spAutoFit/>
+          </a:bodyPr>
+          <a:lstStyle/>
+          <a:p>
+            <a:r>
+              <a:rPr lang="en-US" sz="1400" b="1" dirty="0">
+                <a:solidFill>
+                  <a:srgbClr val="16211E"/>
+                </a:solidFill>
+                <a:latin typeface="Calibri" pitchFamily="34" charset="0"/>
+                <a:ea typeface="Calibri" pitchFamily="34" charset="-122"/>
+                <a:cs typeface="Calibri" pitchFamily="34" charset="-120"/>
+              </a:rPr>
+              <a:t>C</a:t>
+            </a:r>
+            <a:r>
+              <a:rPr kumimoji="0" lang="en-US" sz="1400" b="1" i="0" u="none" strike="noStrike" kern="1200" cap="none" spc="0" normalizeH="0" baseline="0" noProof="0" dirty="0" err="1">
+                <a:ln>
+                  <a:noFill/>
+                </a:ln>
+                <a:solidFill>
+                  <a:srgbClr val="16211E"/>
+                </a:solidFill>
+                <a:effectLst/>
+                <a:uLnTx/>
+                <a:uFillTx/>
+                <a:latin typeface="Calibri" pitchFamily="34" charset="0"/>
+                <a:ea typeface="Calibri" pitchFamily="34" charset="-122"/>
+                <a:cs typeface="Calibri" pitchFamily="34" charset="-120"/>
+              </a:rPr>
+              <a:t>ompliance</a:t>
+            </a:r>
+            <a:endParaRPr lang="en-GB" dirty="0"/>
+          </a:p>
+        </p:txBody>
+      </p:sp>
+      <p:sp>
+        <p:nvSpPr>
+          <p:cNvPr id="34" name="Text 15">
+            <a:extLst>
+              <a:ext uri="{FF2B5EF4-FFF2-40B4-BE49-F238E27FC236}">
+                <a16:creationId xmlns:a16="http://schemas.microsoft.com/office/drawing/2014/main" id="{FBC68662-6999-3504-A7BC-7667B3F8FFF3}"/>
+              </a:ext>
+            </a:extLst>
+          </p:cNvPr>
+          <p:cNvSpPr txBox="1"/>
+          <p:nvPr/>
+        </p:nvSpPr>
+        <p:spPr>
+          <a:xfrm>
+            <a:off x="5303520" y="4435455"/>
+            <a:ext cx="4754880" cy="365760"/>
+          </a:xfrm>
+          <a:prstGeom prst="rect">
+            <a:avLst/>
+          </a:prstGeom>
+          <a:noFill/>
+          <a:ln/>
+        </p:spPr>
+        <p:txBody>
+          <a:bodyPr wrap="square" lIns="0" tIns="0" rIns="0" bIns="0" rtlCol="0" anchor="ctr"/>
+          <a:lstStyle/>
+          <a:p>
+            <a:pPr marL="0" indent="0">
+              <a:buNone/>
+            </a:pPr>
+            <a:r>
+              <a:rPr lang="en-US" sz="1150" dirty="0"/>
+              <a:t>Non-negotiable spend</a:t>
+            </a:r>
+          </a:p>
+        </p:txBody>
+      </p:sp>
+      <p:sp>
+        <p:nvSpPr>
+          <p:cNvPr id="36" name="Text 16">
+            <a:extLst>
+              <a:ext uri="{FF2B5EF4-FFF2-40B4-BE49-F238E27FC236}">
+                <a16:creationId xmlns:a16="http://schemas.microsoft.com/office/drawing/2014/main" id="{A0315F99-5FF9-C772-D5E8-EAB1771A3726}"/>
+              </a:ext>
+            </a:extLst>
+          </p:cNvPr>
+          <p:cNvSpPr txBox="1"/>
+          <p:nvPr/>
+        </p:nvSpPr>
+        <p:spPr>
+          <a:xfrm>
+            <a:off x="10058400" y="4020576"/>
+            <a:ext cx="1463040" cy="274320"/>
+          </a:xfrm>
+          <a:prstGeom prst="rect">
+            <a:avLst/>
+          </a:prstGeom>
+          <a:noFill/>
+          <a:ln/>
+        </p:spPr>
+        <p:txBody>
+          <a:bodyPr wrap="square" lIns="0" tIns="0" rIns="0" bIns="0" rtlCol="0" anchor="ctr"/>
+          <a:lstStyle/>
+          <a:p>
+            <a:pPr marL="0" indent="0" algn="r">
+              <a:buNone/>
+            </a:pPr>
+            <a:r>
+              <a:rPr lang="en-US" sz="1050" b="1" dirty="0">
+                <a:solidFill>
+                  <a:srgbClr val="2E7D68"/>
+                </a:solidFill>
+                <a:latin typeface="Calibri" pitchFamily="34" charset="0"/>
+                <a:ea typeface="Calibri" pitchFamily="34" charset="-122"/>
+                <a:cs typeface="Calibri" pitchFamily="34" charset="-120"/>
+              </a:rPr>
+              <a:t>Revenue</a:t>
+            </a:r>
+            <a:endParaRPr lang="en-US" sz="1050" dirty="0"/>
           </a:p>
         </p:txBody>
       </p:sp>
@@ -2682,6 +2530,7 @@
         <a:solidFill>
           <a:srgbClr val="FFFFFF"/>
         </a:solidFill>
+        <a:effectLst/>
       </p:bgPr>
     </p:bg>
     <p:spTree>
@@ -2719,11 +2568,11 @@
           <a:bodyPr wrap="square" lIns="0" tIns="0" rIns="0" bIns="0" rtlCol="0" anchor="ctr"/>
           <a:lstStyle/>
           <a:p>
-            <a:pPr indent="0" marL="0">
-              <a:buNone/>
-            </a:pPr>
-            <a:r>
-              <a:rPr lang="en-US" sz="1000" b="1" spc="220" kern="0" dirty="0">
+            <a:pPr marL="0" indent="0">
+              <a:buNone/>
+            </a:pPr>
+            <a:r>
+              <a:rPr lang="en-US" sz="1000" b="1" kern="0" spc="220" dirty="0">
                 <a:solidFill>
                   <a:srgbClr val="C8892F"/>
                 </a:solidFill>
@@ -2758,7 +2607,7 @@
           <a:bodyPr wrap="square" lIns="0" tIns="0" rIns="0" bIns="0" rtlCol="0" anchor="ctr"/>
           <a:lstStyle/>
           <a:p>
-            <a:pPr indent="0" marL="0">
+            <a:pPr marL="0" indent="0">
               <a:buNone/>
             </a:pPr>
             <a:r>
@@ -2770,7 +2619,7 @@
                 <a:ea typeface="Cambria" pitchFamily="34" charset="-122"/>
                 <a:cs typeface="Cambria" pitchFamily="34" charset="-120"/>
               </a:rPr>
-              <a:t>Three hypotheses I would arrive with</a:t>
+              <a:t>Three things I'd check first</a:t>
             </a:r>
             <a:endParaRPr lang="en-US" sz="3000" dirty="0"/>
           </a:p>
@@ -2797,7 +2646,7 @@
           <a:bodyPr wrap="square" lIns="0" tIns="0" rIns="0" bIns="0" rtlCol="0" anchor="ctr"/>
           <a:lstStyle/>
           <a:p>
-            <a:pPr indent="0" marL="0">
+            <a:pPr marL="0" indent="0">
               <a:buNone/>
             </a:pPr>
             <a:r>
@@ -2809,7 +2658,7 @@
                 <a:ea typeface="Calibri" pitchFamily="34" charset="-122"/>
                 <a:cs typeface="Calibri" pitchFamily="34" charset="-120"/>
               </a:rPr>
-              <a:t>Each is a question with a data test attached — not a conclusion.</a:t>
+              <a:t>These are questions, not answers. Each one has something I can go and check.</a:t>
             </a:r>
             <a:endParaRPr lang="en-US" sz="1350" dirty="0"/>
           </a:p>
@@ -2841,6 +2690,13 @@
             <a:prstDash val="solid"/>
           </a:ln>
         </p:spPr>
+        <p:txBody>
+          <a:bodyPr/>
+          <a:lstStyle/>
+          <a:p>
+            <a:endParaRPr lang="en-GB"/>
+          </a:p>
+        </p:txBody>
       </p:sp>
       <p:sp>
         <p:nvSpPr>
@@ -2861,6 +2717,13 @@
           </a:solidFill>
           <a:ln/>
         </p:spPr>
+        <p:txBody>
+          <a:bodyPr/>
+          <a:lstStyle/>
+          <a:p>
+            <a:endParaRPr lang="en-GB"/>
+          </a:p>
+        </p:txBody>
       </p:sp>
       <p:sp>
         <p:nvSpPr>
@@ -2883,7 +2746,7 @@
           <a:bodyPr wrap="square" lIns="0" tIns="0" rIns="0" bIns="0" rtlCol="0" anchor="ctr"/>
           <a:lstStyle/>
           <a:p>
-            <a:pPr algn="ctr" indent="0" marL="0">
+            <a:pPr marL="0" indent="0" algn="ctr">
               <a:buNone/>
             </a:pPr>
             <a:r>
@@ -2922,7 +2785,7 @@
           <a:bodyPr wrap="square" lIns="0" tIns="0" rIns="0" bIns="0" rtlCol="0" anchor="ctr"/>
           <a:lstStyle/>
           <a:p>
-            <a:pPr indent="0" marL="0">
+            <a:pPr marL="0" indent="0">
               <a:buNone/>
             </a:pPr>
             <a:r>
@@ -2934,7 +2797,7 @@
                 <a:ea typeface="Cambria" pitchFamily="34" charset="-122"/>
                 <a:cs typeface="Cambria" pitchFamily="34" charset="-120"/>
               </a:rPr>
-              <a:t>Delivery mix</a:t>
+              <a:t>Who does the work</a:t>
             </a:r>
             <a:endParaRPr lang="en-US" sz="1900" dirty="0"/>
           </a:p>
@@ -2961,7 +2824,7 @@
           <a:bodyPr wrap="square" lIns="0" tIns="0" rIns="0" bIns="0" rtlCol="0" anchor="t"/>
           <a:lstStyle/>
           <a:p>
-            <a:pPr indent="0" marL="0">
+            <a:pPr marL="0" indent="0">
               <a:lnSpc>
                 <a:spcPts val="1700"/>
               </a:lnSpc>
@@ -2976,7 +2839,7 @@
                 <a:ea typeface="Calibri" pitchFamily="34" charset="-122"/>
                 <a:cs typeface="Calibri" pitchFamily="34" charset="-120"/>
               </a:rPr>
-              <a:t>Pobl expanded its in-house trades team by c.50% — 34 roles — in 2024, alongside an 11-lot framework for responsive repairs, voids and out-of-hours.</a:t>
+              <a:t>Pobl grew its in-house trades team by about half (34 roles) in 2024. There is also a contractor framework of 11 lots covering repairs, voids and out-of-hours.</a:t>
             </a:r>
             <a:endParaRPr lang="en-US" sz="1200" dirty="0"/>
           </a:p>
@@ -3003,11 +2866,11 @@
           <a:bodyPr wrap="square" lIns="0" tIns="0" rIns="0" bIns="0" rtlCol="0" anchor="ctr"/>
           <a:lstStyle/>
           <a:p>
-            <a:pPr indent="0" marL="0">
-              <a:buNone/>
-            </a:pPr>
-            <a:r>
-              <a:rPr lang="en-US" sz="900" b="1" spc="180" kern="0" dirty="0">
+            <a:pPr marL="0" indent="0">
+              <a:buNone/>
+            </a:pPr>
+            <a:r>
+              <a:rPr lang="en-US" sz="900" b="1" kern="0" spc="180" dirty="0">
                 <a:solidFill>
                   <a:srgbClr val="C8892F"/>
                 </a:solidFill>
@@ -3015,7 +2878,7 @@
                 <a:ea typeface="Calibri" pitchFamily="34" charset="-122"/>
                 <a:cs typeface="Calibri" pitchFamily="34" charset="-120"/>
               </a:rPr>
-              <a:t>THE TEST</a:t>
+              <a:t>WHAT I'D CHECK</a:t>
             </a:r>
             <a:endParaRPr lang="en-US" sz="900" dirty="0"/>
           </a:p>
@@ -3042,7 +2905,7 @@
           <a:bodyPr wrap="square" lIns="0" tIns="0" rIns="0" bIns="0" rtlCol="0" anchor="t"/>
           <a:lstStyle/>
           <a:p>
-            <a:pPr indent="0" marL="0">
+            <a:pPr marL="0" indent="0">
               <a:lnSpc>
                 <a:spcPts val="1600"/>
               </a:lnSpc>
@@ -3057,7 +2920,7 @@
                 <a:ea typeface="Calibri" pitchFamily="34" charset="-122"/>
                 <a:cs typeface="Calibri" pitchFamily="34" charset="-120"/>
               </a:rPr>
-              <a:t>Has external spend stepped down in proportion to the capacity we insourced, or are we carrying both?</a:t>
+              <a:t>Has contractor spend come down now we do more in-house, or are we paying for both?</a:t>
             </a:r>
             <a:endParaRPr lang="en-US" sz="1150" dirty="0"/>
           </a:p>
@@ -3089,6 +2952,13 @@
             <a:prstDash val="solid"/>
           </a:ln>
         </p:spPr>
+        <p:txBody>
+          <a:bodyPr/>
+          <a:lstStyle/>
+          <a:p>
+            <a:endParaRPr lang="en-GB"/>
+          </a:p>
+        </p:txBody>
       </p:sp>
       <p:sp>
         <p:nvSpPr>
@@ -3109,6 +2979,13 @@
           </a:solidFill>
           <a:ln/>
         </p:spPr>
+        <p:txBody>
+          <a:bodyPr/>
+          <a:lstStyle/>
+          <a:p>
+            <a:endParaRPr lang="en-GB"/>
+          </a:p>
+        </p:txBody>
       </p:sp>
       <p:sp>
         <p:nvSpPr>
@@ -3131,7 +3008,7 @@
           <a:bodyPr wrap="square" lIns="0" tIns="0" rIns="0" bIns="0" rtlCol="0" anchor="ctr"/>
           <a:lstStyle/>
           <a:p>
-            <a:pPr algn="ctr" indent="0" marL="0">
+            <a:pPr marL="0" indent="0" algn="ctr">
               <a:buNone/>
             </a:pPr>
             <a:r>
@@ -3170,7 +3047,7 @@
           <a:bodyPr wrap="square" lIns="0" tIns="0" rIns="0" bIns="0" rtlCol="0" anchor="ctr"/>
           <a:lstStyle/>
           <a:p>
-            <a:pPr indent="0" marL="0">
+            <a:pPr marL="0" indent="0">
               <a:buNone/>
             </a:pPr>
             <a:r>
@@ -3182,7 +3059,7 @@
                 <a:ea typeface="Cambria" pitchFamily="34" charset="-122"/>
                 <a:cs typeface="Cambria" pitchFamily="34" charset="-120"/>
               </a:rPr>
-              <a:t>Regulation</a:t>
+              <a:t>The new repair rules</a:t>
             </a:r>
             <a:endParaRPr lang="en-US" sz="1900" dirty="0"/>
           </a:p>
@@ -3209,7 +3086,7 @@
           <a:bodyPr wrap="square" lIns="0" tIns="0" rIns="0" bIns="0" rtlCol="0" anchor="t"/>
           <a:lstStyle/>
           <a:p>
-            <a:pPr indent="0" marL="0">
+            <a:pPr marL="0" indent="0">
               <a:lnSpc>
                 <a:spcPts val="1700"/>
               </a:lnSpc>
@@ -3224,7 +3101,7 @@
                 <a:ea typeface="Calibri" pitchFamily="34" charset="-122"/>
                 <a:cs typeface="Calibri" pitchFamily="34" charset="-120"/>
               </a:rPr>
-              <a:t>WHQS hazard response took effect 1 April 2026: investigate and remedy within 24 hours each where harm is imminent; 10 then 5 working days otherwise.</a:t>
+              <a:t>From 1 April 2026, WHQS sets response times. Urgent hazards: 24 hours to investigate, 24 to fix. Everything else: 10 working days, then 5.</a:t>
             </a:r>
             <a:endParaRPr lang="en-US" sz="1200" dirty="0"/>
           </a:p>
@@ -3251,11 +3128,11 @@
           <a:bodyPr wrap="square" lIns="0" tIns="0" rIns="0" bIns="0" rtlCol="0" anchor="ctr"/>
           <a:lstStyle/>
           <a:p>
-            <a:pPr indent="0" marL="0">
-              <a:buNone/>
-            </a:pPr>
-            <a:r>
-              <a:rPr lang="en-US" sz="900" b="1" spc="180" kern="0" dirty="0">
+            <a:pPr marL="0" indent="0">
+              <a:buNone/>
+            </a:pPr>
+            <a:r>
+              <a:rPr lang="en-US" sz="900" b="1" kern="0" spc="180" dirty="0">
                 <a:solidFill>
                   <a:srgbClr val="C8892F"/>
                 </a:solidFill>
@@ -3263,7 +3140,7 @@
                 <a:ea typeface="Calibri" pitchFamily="34" charset="-122"/>
                 <a:cs typeface="Calibri" pitchFamily="34" charset="-120"/>
               </a:rPr>
-              <a:t>THE TEST</a:t>
+              <a:t>WHAT I'D CHECK</a:t>
             </a:r>
             <a:endParaRPr lang="en-US" sz="900" dirty="0"/>
           </a:p>
@@ -3290,7 +3167,7 @@
           <a:bodyPr wrap="square" lIns="0" tIns="0" rIns="0" bIns="0" rtlCol="0" anchor="t"/>
           <a:lstStyle/>
           <a:p>
-            <a:pPr indent="0" marL="0">
+            <a:pPr marL="0" indent="0">
               <a:lnSpc>
                 <a:spcPts val="1600"/>
               </a:lnSpc>
@@ -3305,7 +3182,7 @@
                 <a:ea typeface="Calibri" pitchFamily="34" charset="-122"/>
                 <a:cs typeface="Calibri" pitchFamily="34" charset="-120"/>
               </a:rPr>
-              <a:t>What has that done to job volume, out-of-hours and premium call-off, and to how densely we can schedule?</a:t>
+              <a:t>How much extra out-of-hours and emergency work has this created, and is it harder to plan jobs?</a:t>
             </a:r>
             <a:endParaRPr lang="en-US" sz="1150" dirty="0"/>
           </a:p>
@@ -3337,6 +3214,13 @@
             <a:prstDash val="solid"/>
           </a:ln>
         </p:spPr>
+        <p:txBody>
+          <a:bodyPr/>
+          <a:lstStyle/>
+          <a:p>
+            <a:endParaRPr lang="en-GB"/>
+          </a:p>
+        </p:txBody>
       </p:sp>
       <p:sp>
         <p:nvSpPr>
@@ -3357,6 +3241,13 @@
           </a:solidFill>
           <a:ln/>
         </p:spPr>
+        <p:txBody>
+          <a:bodyPr/>
+          <a:lstStyle/>
+          <a:p>
+            <a:endParaRPr lang="en-GB"/>
+          </a:p>
+        </p:txBody>
       </p:sp>
       <p:sp>
         <p:nvSpPr>
@@ -3379,7 +3270,7 @@
           <a:bodyPr wrap="square" lIns="0" tIns="0" rIns="0" bIns="0" rtlCol="0" anchor="ctr"/>
           <a:lstStyle/>
           <a:p>
-            <a:pPr algn="ctr" indent="0" marL="0">
+            <a:pPr marL="0" indent="0" algn="ctr">
               <a:buNone/>
             </a:pPr>
             <a:r>
@@ -3418,7 +3309,7 @@
           <a:bodyPr wrap="square" lIns="0" tIns="0" rIns="0" bIns="0" rtlCol="0" anchor="ctr"/>
           <a:lstStyle/>
           <a:p>
-            <a:pPr indent="0" marL="0">
+            <a:pPr marL="0" indent="0">
               <a:buNone/>
             </a:pPr>
             <a:r>
@@ -3430,7 +3321,7 @@
                 <a:ea typeface="Cambria" pitchFamily="34" charset="-122"/>
                 <a:cs typeface="Cambria" pitchFamily="34" charset="-120"/>
               </a:rPr>
-              <a:t>Price</a:t>
+              <a:t>Costs going up</a:t>
             </a:r>
             <a:endParaRPr lang="en-US" sz="1900" dirty="0"/>
           </a:p>
@@ -3457,7 +3348,7 @@
           <a:bodyPr wrap="square" lIns="0" tIns="0" rIns="0" bIns="0" rtlCol="0" anchor="t"/>
           <a:lstStyle/>
           <a:p>
-            <a:pPr indent="0" marL="0">
+            <a:pPr marL="0" indent="0">
               <a:lnSpc>
                 <a:spcPts val="1700"/>
               </a:lnSpc>
@@ -3472,7 +3363,7 @@
                 <a:ea typeface="Calibri" pitchFamily="34" charset="-122"/>
                 <a:cs typeface="Calibri" pitchFamily="34" charset="-120"/>
               </a:rPr>
-              <a:t>Sector surveys put expected responsive repairs cost increases at c.23% this year, against c.10% in the regulator's global accounts.</a:t>
+              <a:t>Repairs costs across the sector are expected to rise by about 23% this year. The regulator's published figures suggested nearer 10%.</a:t>
             </a:r>
             <a:endParaRPr lang="en-US" sz="1200" dirty="0"/>
           </a:p>
@@ -3499,11 +3390,11 @@
           <a:bodyPr wrap="square" lIns="0" tIns="0" rIns="0" bIns="0" rtlCol="0" anchor="ctr"/>
           <a:lstStyle/>
           <a:p>
-            <a:pPr indent="0" marL="0">
-              <a:buNone/>
-            </a:pPr>
-            <a:r>
-              <a:rPr lang="en-US" sz="900" b="1" spc="180" kern="0" dirty="0">
+            <a:pPr marL="0" indent="0">
+              <a:buNone/>
+            </a:pPr>
+            <a:r>
+              <a:rPr lang="en-US" sz="900" b="1" kern="0" spc="180" dirty="0">
                 <a:solidFill>
                   <a:srgbClr val="C8892F"/>
                 </a:solidFill>
@@ -3511,7 +3402,7 @@
                 <a:ea typeface="Calibri" pitchFamily="34" charset="-122"/>
                 <a:cs typeface="Calibri" pitchFamily="34" charset="-120"/>
               </a:rPr>
-              <a:t>THE TEST</a:t>
+              <a:t>WHAT I'D CHECK</a:t>
             </a:r>
             <a:endParaRPr lang="en-US" sz="900" dirty="0"/>
           </a:p>
@@ -3538,7 +3429,7 @@
           <a:bodyPr wrap="square" lIns="0" tIns="0" rIns="0" bIns="0" rtlCol="0" anchor="t"/>
           <a:lstStyle/>
           <a:p>
-            <a:pPr indent="0" marL="0">
+            <a:pPr marL="0" indent="0">
               <a:lnSpc>
                 <a:spcPts val="1600"/>
               </a:lnSpc>
@@ -3553,7 +3444,7 @@
                 <a:ea typeface="Calibri" pitchFamily="34" charset="-122"/>
                 <a:cs typeface="Calibri" pitchFamily="34" charset="-120"/>
               </a:rPr>
-              <a:t>On like-for-like jobs, how much of our movement is rate and materials rather than volume?</a:t>
+              <a:t>For the same type of job, how much of our increase is price rather than more jobs?</a:t>
             </a:r>
             <a:endParaRPr lang="en-US" sz="1150" dirty="0"/>
           </a:p>
@@ -3580,7 +3471,7 @@
           <a:bodyPr wrap="square" lIns="0" tIns="0" rIns="0" bIns="0" rtlCol="0" anchor="ctr"/>
           <a:lstStyle/>
           <a:p>
-            <a:pPr indent="0" marL="0">
+            <a:pPr marL="0" indent="0">
               <a:buNone/>
             </a:pPr>
             <a:r>
@@ -3592,7 +3483,7 @@
                 <a:ea typeface="Calibri" pitchFamily="34" charset="-122"/>
                 <a:cs typeface="Calibri" pitchFamily="34" charset="-120"/>
               </a:rPr>
-              <a:t>Sources: Codi/Pobl published announcements and tender notices; Welsh Government WHQS hazard-response statement; UK sector cost surveys.</a:t>
+              <a:t>Sources: Pobl announcements and tender notices; Welsh Government WHQS statement; UK-wide sector cost surveys.</a:t>
             </a:r>
             <a:endParaRPr lang="en-US" sz="950" dirty="0"/>
           </a:p>
@@ -3619,7 +3510,7 @@
           <a:bodyPr wrap="square" lIns="0" tIns="0" rIns="0" bIns="0" rtlCol="0" anchor="ctr"/>
           <a:lstStyle/>
           <a:p>
-            <a:pPr algn="l" indent="0" marL="0">
+            <a:pPr marL="0" indent="0" algn="l">
               <a:buNone/>
             </a:pPr>
             <a:r>
@@ -3658,7 +3549,7 @@
           <a:bodyPr wrap="square" lIns="0" tIns="0" rIns="0" bIns="0" rtlCol="0" anchor="ctr"/>
           <a:lstStyle/>
           <a:p>
-            <a:pPr algn="r" indent="0" marL="0">
+            <a:pPr marL="0" indent="0" algn="r">
               <a:buNone/>
             </a:pPr>
             <a:r>
@@ -3692,6 +3583,7 @@
         <a:solidFill>
           <a:srgbClr val="FFFFFF"/>
         </a:solidFill>
+        <a:effectLst/>
       </p:bgPr>
     </p:bg>
     <p:spTree>
@@ -3729,11 +3621,11 @@
           <a:bodyPr wrap="square" lIns="0" tIns="0" rIns="0" bIns="0" rtlCol="0" anchor="ctr"/>
           <a:lstStyle/>
           <a:p>
-            <a:pPr indent="0" marL="0">
-              <a:buNone/>
-            </a:pPr>
-            <a:r>
-              <a:rPr lang="en-US" sz="1000" b="1" spc="220" kern="0" dirty="0">
+            <a:pPr marL="0" indent="0">
+              <a:buNone/>
+            </a:pPr>
+            <a:r>
+              <a:rPr lang="en-US" sz="1000" b="1" kern="0" spc="220" dirty="0">
                 <a:solidFill>
                   <a:srgbClr val="C8892F"/>
                 </a:solidFill>
@@ -3768,7 +3660,7 @@
           <a:bodyPr wrap="square" lIns="0" tIns="0" rIns="0" bIns="0" rtlCol="0" anchor="ctr"/>
           <a:lstStyle/>
           <a:p>
-            <a:pPr indent="0" marL="0">
+            <a:pPr marL="0" indent="0">
               <a:buNone/>
             </a:pPr>
             <a:r>
@@ -3812,6 +3704,13 @@
             <a:prstDash val="solid"/>
           </a:ln>
         </p:spPr>
+        <p:txBody>
+          <a:bodyPr/>
+          <a:lstStyle/>
+          <a:p>
+            <a:endParaRPr lang="en-GB"/>
+          </a:p>
+        </p:txBody>
       </p:sp>
       <p:sp>
         <p:nvSpPr>
@@ -3834,7 +3733,7 @@
           <a:bodyPr wrap="square" lIns="0" tIns="0" rIns="0" bIns="0" rtlCol="0" anchor="ctr"/>
           <a:lstStyle/>
           <a:p>
-            <a:pPr algn="ctr" indent="0" marL="0">
+            <a:pPr marL="0" indent="0" algn="ctr">
               <a:buNone/>
             </a:pPr>
             <a:r>
@@ -3846,7 +3745,7 @@
                 <a:ea typeface="Calibri" pitchFamily="34" charset="-122"/>
                 <a:cs typeface="Calibri" pitchFamily="34" charset="-120"/>
               </a:rPr>
-              <a:t>Actuals  +  committed cost  +  ( remaining demand  ×  evidenced unit cost )  =  year-end position</a:t>
+              <a:t>Actuals  +  committed cost  +  ( remaining demand  ×  evidenced unit cost )  =  FYF</a:t>
             </a:r>
             <a:endParaRPr lang="en-US" sz="1600" dirty="0"/>
           </a:p>
@@ -3871,6 +3770,13 @@
           </a:solidFill>
           <a:ln/>
         </p:spPr>
+        <p:txBody>
+          <a:bodyPr/>
+          <a:lstStyle/>
+          <a:p>
+            <a:endParaRPr lang="en-GB"/>
+          </a:p>
+        </p:txBody>
       </p:sp>
       <p:sp>
         <p:nvSpPr>
@@ -3893,7 +3799,7 @@
           <a:bodyPr wrap="square" lIns="0" tIns="0" rIns="0" bIns="0" rtlCol="0" anchor="ctr"/>
           <a:lstStyle/>
           <a:p>
-            <a:pPr algn="ctr" indent="0" marL="0">
+            <a:pPr marL="0" indent="0" algn="ctr">
               <a:buNone/>
             </a:pPr>
             <a:r>
@@ -3932,7 +3838,7 @@
           <a:bodyPr wrap="square" lIns="0" tIns="0" rIns="0" bIns="0" rtlCol="0" anchor="ctr"/>
           <a:lstStyle/>
           <a:p>
-            <a:pPr indent="0" marL="0">
+            <a:pPr marL="0" indent="0">
               <a:buNone/>
             </a:pPr>
             <a:r>
@@ -4087,6 +3993,13 @@
           </a:solidFill>
           <a:ln/>
         </p:spPr>
+        <p:txBody>
+          <a:bodyPr/>
+          <a:lstStyle/>
+          <a:p>
+            <a:endParaRPr lang="en-GB"/>
+          </a:p>
+        </p:txBody>
       </p:sp>
       <p:sp>
         <p:nvSpPr>
@@ -4109,7 +4022,7 @@
           <a:bodyPr wrap="square" lIns="0" tIns="0" rIns="0" bIns="0" rtlCol="0" anchor="ctr"/>
           <a:lstStyle/>
           <a:p>
-            <a:pPr algn="ctr" indent="0" marL="0">
+            <a:pPr marL="0" indent="0" algn="ctr">
               <a:buNone/>
             </a:pPr>
             <a:r>
@@ -4148,7 +4061,7 @@
           <a:bodyPr wrap="square" lIns="0" tIns="0" rIns="0" bIns="0" rtlCol="0" anchor="ctr"/>
           <a:lstStyle/>
           <a:p>
-            <a:pPr indent="0" marL="0">
+            <a:pPr marL="0" indent="0">
               <a:buNone/>
             </a:pPr>
             <a:r>
@@ -4303,6 +4216,13 @@
           </a:solidFill>
           <a:ln/>
         </p:spPr>
+        <p:txBody>
+          <a:bodyPr/>
+          <a:lstStyle/>
+          <a:p>
+            <a:endParaRPr lang="en-GB"/>
+          </a:p>
+        </p:txBody>
       </p:sp>
       <p:sp>
         <p:nvSpPr>
@@ -4325,7 +4245,7 @@
           <a:bodyPr wrap="square" lIns="0" tIns="0" rIns="0" bIns="0" rtlCol="0" anchor="ctr"/>
           <a:lstStyle/>
           <a:p>
-            <a:pPr algn="ctr" indent="0" marL="0">
+            <a:pPr marL="0" indent="0" algn="ctr">
               <a:buNone/>
             </a:pPr>
             <a:r>
@@ -4364,7 +4284,7 @@
           <a:bodyPr wrap="square" lIns="0" tIns="0" rIns="0" bIns="0" rtlCol="0" anchor="ctr"/>
           <a:lstStyle/>
           <a:p>
-            <a:pPr indent="0" marL="0">
+            <a:pPr marL="0" indent="0">
               <a:buNone/>
             </a:pPr>
             <a:r>
@@ -4526,6 +4446,13 @@
             <a:prstDash val="solid"/>
           </a:ln>
         </p:spPr>
+        <p:txBody>
+          <a:bodyPr/>
+          <a:lstStyle/>
+          <a:p>
+            <a:endParaRPr lang="en-GB"/>
+          </a:p>
+        </p:txBody>
       </p:sp>
       <p:sp>
         <p:nvSpPr>
@@ -4548,7 +4475,7 @@
           <a:bodyPr wrap="square" lIns="0" tIns="0" rIns="0" bIns="0" rtlCol="0" anchor="ctr"/>
           <a:lstStyle/>
           <a:p>
-            <a:pPr indent="0" marL="0">
+            <a:pPr marL="0" indent="0">
               <a:lnSpc>
                 <a:spcPts val="1900"/>
               </a:lnSpc>
@@ -4565,12 +4492,6 @@
               </a:rPr>
               <a:t>Show the delivery forecast before mitigation. </a:t>
             </a:r>
-            <a:pPr indent="0" marL="0">
-              <a:lnSpc>
-                <a:spcPts val="1900"/>
-              </a:lnSpc>
-              <a:buNone/>
-            </a:pPr>
             <a:r>
               <a:rPr lang="en-US" sz="1350" dirty="0">
                 <a:solidFill>
@@ -4607,7 +4528,7 @@
           <a:bodyPr wrap="square" lIns="0" tIns="0" rIns="0" bIns="0" rtlCol="0" anchor="ctr"/>
           <a:lstStyle/>
           <a:p>
-            <a:pPr algn="l" indent="0" marL="0">
+            <a:pPr marL="0" indent="0" algn="l">
               <a:buNone/>
             </a:pPr>
             <a:r>
@@ -4646,7 +4567,7 @@
           <a:bodyPr wrap="square" lIns="0" tIns="0" rIns="0" bIns="0" rtlCol="0" anchor="ctr"/>
           <a:lstStyle/>
           <a:p>
-            <a:pPr algn="r" indent="0" marL="0">
+            <a:pPr marL="0" indent="0" algn="r">
               <a:buNone/>
             </a:pPr>
             <a:r>
@@ -4680,6 +4601,7 @@
         <a:solidFill>
           <a:srgbClr val="FFFFFF"/>
         </a:solidFill>
+        <a:effectLst/>
       </p:bgPr>
     </p:bg>
     <p:spTree>
@@ -4717,11 +4639,11 @@
           <a:bodyPr wrap="square" lIns="0" tIns="0" rIns="0" bIns="0" rtlCol="0" anchor="ctr"/>
           <a:lstStyle/>
           <a:p>
-            <a:pPr indent="0" marL="0">
-              <a:buNone/>
-            </a:pPr>
-            <a:r>
-              <a:rPr lang="en-US" sz="1000" b="1" spc="220" kern="0" dirty="0">
+            <a:pPr marL="0" indent="0">
+              <a:buNone/>
+            </a:pPr>
+            <a:r>
+              <a:rPr lang="en-US" sz="1000" b="1" kern="0" spc="220" dirty="0">
                 <a:solidFill>
                   <a:srgbClr val="C8892F"/>
                 </a:solidFill>
@@ -4756,7 +4678,7 @@
           <a:bodyPr wrap="square" lIns="0" tIns="0" rIns="0" bIns="0" rtlCol="0" anchor="ctr"/>
           <a:lstStyle/>
           <a:p>
-            <a:pPr indent="0" marL="0">
+            <a:pPr marL="0" indent="0">
               <a:buNone/>
             </a:pPr>
             <a:r>
@@ -4793,6 +4715,13 @@
           </a:solidFill>
           <a:ln/>
         </p:spPr>
+        <p:txBody>
+          <a:bodyPr/>
+          <a:lstStyle/>
+          <a:p>
+            <a:endParaRPr lang="en-GB"/>
+          </a:p>
+        </p:txBody>
       </p:sp>
       <p:sp>
         <p:nvSpPr>
@@ -4815,7 +4744,7 @@
           <a:bodyPr wrap="square" lIns="0" tIns="0" rIns="0" bIns="0" rtlCol="0" anchor="ctr"/>
           <a:lstStyle/>
           <a:p>
-            <a:pPr algn="ctr" indent="0" marL="0">
+            <a:pPr marL="0" indent="0" algn="ctr">
               <a:buNone/>
             </a:pPr>
             <a:r>
@@ -4854,7 +4783,7 @@
           <a:bodyPr wrap="square" lIns="0" tIns="0" rIns="0" bIns="0" rtlCol="0" anchor="ctr"/>
           <a:lstStyle/>
           <a:p>
-            <a:pPr indent="0" marL="0">
+            <a:pPr marL="0" indent="0">
               <a:buNone/>
             </a:pPr>
             <a:r>
@@ -4893,7 +4822,7 @@
           <a:bodyPr wrap="square" lIns="0" tIns="0" rIns="0" bIns="0" rtlCol="0" anchor="ctr"/>
           <a:lstStyle/>
           <a:p>
-            <a:pPr indent="0" marL="0">
+            <a:pPr marL="0" indent="0">
               <a:buNone/>
             </a:pPr>
             <a:r>
@@ -4932,7 +4861,7 @@
           <a:bodyPr wrap="square" lIns="0" tIns="0" rIns="0" bIns="0" rtlCol="0" anchor="ctr"/>
           <a:lstStyle/>
           <a:p>
-            <a:pPr indent="0" marL="0">
+            <a:pPr marL="0" indent="0">
               <a:buNone/>
             </a:pPr>
             <a:r>
@@ -4969,6 +4898,13 @@
           </a:solidFill>
           <a:ln/>
         </p:spPr>
+        <p:txBody>
+          <a:bodyPr/>
+          <a:lstStyle/>
+          <a:p>
+            <a:endParaRPr lang="en-GB"/>
+          </a:p>
+        </p:txBody>
       </p:sp>
       <p:sp>
         <p:nvSpPr>
@@ -4991,7 +4927,7 @@
           <a:bodyPr wrap="square" lIns="0" tIns="0" rIns="0" bIns="0" rtlCol="0" anchor="ctr"/>
           <a:lstStyle/>
           <a:p>
-            <a:pPr algn="ctr" indent="0" marL="0">
+            <a:pPr marL="0" indent="0" algn="ctr">
               <a:buNone/>
             </a:pPr>
             <a:r>
@@ -5030,7 +4966,7 @@
           <a:bodyPr wrap="square" lIns="0" tIns="0" rIns="0" bIns="0" rtlCol="0" anchor="ctr"/>
           <a:lstStyle/>
           <a:p>
-            <a:pPr indent="0" marL="0">
+            <a:pPr marL="0" indent="0">
               <a:buNone/>
             </a:pPr>
             <a:r>
@@ -5069,7 +5005,7 @@
           <a:bodyPr wrap="square" lIns="0" tIns="0" rIns="0" bIns="0" rtlCol="0" anchor="ctr"/>
           <a:lstStyle/>
           <a:p>
-            <a:pPr indent="0" marL="0">
+            <a:pPr marL="0" indent="0">
               <a:buNone/>
             </a:pPr>
             <a:r>
@@ -5108,7 +5044,7 @@
           <a:bodyPr wrap="square" lIns="0" tIns="0" rIns="0" bIns="0" rtlCol="0" anchor="ctr"/>
           <a:lstStyle/>
           <a:p>
-            <a:pPr indent="0" marL="0">
+            <a:pPr marL="0" indent="0">
               <a:buNone/>
             </a:pPr>
             <a:r>
@@ -5145,6 +5081,13 @@
           </a:solidFill>
           <a:ln/>
         </p:spPr>
+        <p:txBody>
+          <a:bodyPr/>
+          <a:lstStyle/>
+          <a:p>
+            <a:endParaRPr lang="en-GB"/>
+          </a:p>
+        </p:txBody>
       </p:sp>
       <p:sp>
         <p:nvSpPr>
@@ -5167,7 +5110,7 @@
           <a:bodyPr wrap="square" lIns="0" tIns="0" rIns="0" bIns="0" rtlCol="0" anchor="ctr"/>
           <a:lstStyle/>
           <a:p>
-            <a:pPr algn="ctr" indent="0" marL="0">
+            <a:pPr marL="0" indent="0" algn="ctr">
               <a:buNone/>
             </a:pPr>
             <a:r>
@@ -5206,7 +5149,7 @@
           <a:bodyPr wrap="square" lIns="0" tIns="0" rIns="0" bIns="0" rtlCol="0" anchor="ctr"/>
           <a:lstStyle/>
           <a:p>
-            <a:pPr indent="0" marL="0">
+            <a:pPr marL="0" indent="0">
               <a:buNone/>
             </a:pPr>
             <a:r>
@@ -5245,7 +5188,7 @@
           <a:bodyPr wrap="square" lIns="0" tIns="0" rIns="0" bIns="0" rtlCol="0" anchor="ctr"/>
           <a:lstStyle/>
           <a:p>
-            <a:pPr indent="0" marL="0">
+            <a:pPr marL="0" indent="0">
               <a:buNone/>
             </a:pPr>
             <a:r>
@@ -5284,7 +5227,7 @@
           <a:bodyPr wrap="square" lIns="0" tIns="0" rIns="0" bIns="0" rtlCol="0" anchor="ctr"/>
           <a:lstStyle/>
           <a:p>
-            <a:pPr indent="0" marL="0">
+            <a:pPr marL="0" indent="0">
               <a:buNone/>
             </a:pPr>
             <a:r>
@@ -5321,6 +5264,13 @@
           </a:solidFill>
           <a:ln/>
         </p:spPr>
+        <p:txBody>
+          <a:bodyPr/>
+          <a:lstStyle/>
+          <a:p>
+            <a:endParaRPr lang="en-GB"/>
+          </a:p>
+        </p:txBody>
       </p:sp>
       <p:sp>
         <p:nvSpPr>
@@ -5343,7 +5293,7 @@
           <a:bodyPr wrap="square" lIns="0" tIns="0" rIns="0" bIns="0" rtlCol="0" anchor="ctr"/>
           <a:lstStyle/>
           <a:p>
-            <a:pPr algn="ctr" indent="0" marL="0">
+            <a:pPr marL="0" indent="0" algn="ctr">
               <a:buNone/>
             </a:pPr>
             <a:r>
@@ -5382,7 +5332,7 @@
           <a:bodyPr wrap="square" lIns="0" tIns="0" rIns="0" bIns="0" rtlCol="0" anchor="ctr"/>
           <a:lstStyle/>
           <a:p>
-            <a:pPr indent="0" marL="0">
+            <a:pPr marL="0" indent="0">
               <a:buNone/>
             </a:pPr>
             <a:r>
@@ -5421,7 +5371,7 @@
           <a:bodyPr wrap="square" lIns="0" tIns="0" rIns="0" bIns="0" rtlCol="0" anchor="ctr"/>
           <a:lstStyle/>
           <a:p>
-            <a:pPr indent="0" marL="0">
+            <a:pPr marL="0" indent="0">
               <a:buNone/>
             </a:pPr>
             <a:r>
@@ -5460,7 +5410,7 @@
           <a:bodyPr wrap="square" lIns="0" tIns="0" rIns="0" bIns="0" rtlCol="0" anchor="ctr"/>
           <a:lstStyle/>
           <a:p>
-            <a:pPr indent="0" marL="0">
+            <a:pPr marL="0" indent="0">
               <a:buNone/>
             </a:pPr>
             <a:r>
@@ -5504,6 +5454,13 @@
             <a:prstDash val="solid"/>
           </a:ln>
         </p:spPr>
+        <p:txBody>
+          <a:bodyPr/>
+          <a:lstStyle/>
+          <a:p>
+            <a:endParaRPr lang="en-GB"/>
+          </a:p>
+        </p:txBody>
       </p:sp>
       <p:sp>
         <p:nvSpPr>
@@ -5526,7 +5483,7 @@
           <a:bodyPr wrap="square" lIns="0" tIns="0" rIns="0" bIns="0" rtlCol="0" anchor="ctr"/>
           <a:lstStyle/>
           <a:p>
-            <a:pPr indent="0" marL="0">
+            <a:pPr marL="0" indent="0">
               <a:lnSpc>
                 <a:spcPts val="1800"/>
               </a:lnSpc>
@@ -5543,12 +5500,6 @@
               </a:rPr>
               <a:t>Watch the second-order effect.  </a:t>
             </a:r>
-            <a:pPr indent="0" marL="0">
-              <a:lnSpc>
-                <a:spcPts val="1800"/>
-              </a:lnSpc>
-              <a:buNone/>
-            </a:pPr>
             <a:r>
               <a:rPr lang="en-US" sz="1300" dirty="0">
                 <a:solidFill>
@@ -5585,7 +5536,7 @@
           <a:bodyPr wrap="square" lIns="0" tIns="0" rIns="0" bIns="0" rtlCol="0" anchor="ctr"/>
           <a:lstStyle/>
           <a:p>
-            <a:pPr algn="l" indent="0" marL="0">
+            <a:pPr marL="0" indent="0" algn="l">
               <a:buNone/>
             </a:pPr>
             <a:r>
@@ -5624,7 +5575,7 @@
           <a:bodyPr wrap="square" lIns="0" tIns="0" rIns="0" bIns="0" rtlCol="0" anchor="ctr"/>
           <a:lstStyle/>
           <a:p>
-            <a:pPr algn="r" indent="0" marL="0">
+            <a:pPr marL="0" indent="0" algn="r">
               <a:buNone/>
             </a:pPr>
             <a:r>
@@ -5658,6 +5609,7 @@
         <a:solidFill>
           <a:srgbClr val="FFFFFF"/>
         </a:solidFill>
+        <a:effectLst/>
       </p:bgPr>
     </p:bg>
     <p:spTree>
@@ -5695,11 +5647,11 @@
           <a:bodyPr wrap="square" lIns="0" tIns="0" rIns="0" bIns="0" rtlCol="0" anchor="ctr"/>
           <a:lstStyle/>
           <a:p>
-            <a:pPr indent="0" marL="0">
-              <a:buNone/>
-            </a:pPr>
-            <a:r>
-              <a:rPr lang="en-US" sz="1000" b="1" spc="220" kern="0" dirty="0">
+            <a:pPr marL="0" indent="0">
+              <a:buNone/>
+            </a:pPr>
+            <a:r>
+              <a:rPr lang="en-US" sz="1000" b="1" kern="0" spc="220" dirty="0">
                 <a:solidFill>
                   <a:srgbClr val="C8892F"/>
                 </a:solidFill>
@@ -5734,7 +5686,7 @@
           <a:bodyPr wrap="square" lIns="0" tIns="0" rIns="0" bIns="0" rtlCol="0" anchor="ctr"/>
           <a:lstStyle/>
           <a:p>
-            <a:pPr indent="0" marL="0">
+            <a:pPr marL="0" indent="0">
               <a:buNone/>
             </a:pPr>
             <a:r>
@@ -5778,6 +5730,13 @@
             <a:prstDash val="solid"/>
           </a:ln>
         </p:spPr>
+        <p:txBody>
+          <a:bodyPr/>
+          <a:lstStyle/>
+          <a:p>
+            <a:endParaRPr lang="en-GB"/>
+          </a:p>
+        </p:txBody>
       </p:sp>
       <p:sp>
         <p:nvSpPr>
@@ -5800,7 +5759,7 @@
           <a:bodyPr wrap="square" lIns="0" tIns="0" rIns="0" bIns="0" rtlCol="0" anchor="ctr"/>
           <a:lstStyle/>
           <a:p>
-            <a:pPr algn="ctr" indent="0" marL="0">
+            <a:pPr marL="0" indent="0" algn="ctr">
               <a:lnSpc>
                 <a:spcPts val="1700"/>
               </a:lnSpc>
@@ -5820,7 +5779,7 @@
             <a:endParaRPr lang="en-US" sz="1350" dirty="0"/>
           </a:p>
           <a:p>
-            <a:pPr algn="ctr" indent="0" marL="0">
+            <a:pPr marL="0" indent="0" algn="ctr">
               <a:lnSpc>
                 <a:spcPts val="1700"/>
               </a:lnSpc>
@@ -5862,7 +5821,7 @@
           <a:bodyPr wrap="square" lIns="0" tIns="0" rIns="0" bIns="0" rtlCol="0" anchor="ctr"/>
           <a:lstStyle/>
           <a:p>
-            <a:pPr algn="ctr" indent="0" marL="0">
+            <a:pPr marL="0" indent="0" algn="ctr">
               <a:buNone/>
             </a:pPr>
             <a:r>
@@ -5906,6 +5865,13 @@
             <a:prstDash val="solid"/>
           </a:ln>
         </p:spPr>
+        <p:txBody>
+          <a:bodyPr/>
+          <a:lstStyle/>
+          <a:p>
+            <a:endParaRPr lang="en-GB"/>
+          </a:p>
+        </p:txBody>
       </p:sp>
       <p:sp>
         <p:nvSpPr>
@@ -5928,7 +5894,7 @@
           <a:bodyPr wrap="square" lIns="0" tIns="0" rIns="0" bIns="0" rtlCol="0" anchor="ctr"/>
           <a:lstStyle/>
           <a:p>
-            <a:pPr algn="ctr" indent="0" marL="0">
+            <a:pPr marL="0" indent="0" algn="ctr">
               <a:lnSpc>
                 <a:spcPts val="1700"/>
               </a:lnSpc>
@@ -5948,7 +5914,7 @@
             <a:endParaRPr lang="en-US" sz="1350" dirty="0"/>
           </a:p>
           <a:p>
-            <a:pPr algn="ctr" indent="0" marL="0">
+            <a:pPr marL="0" indent="0" algn="ctr">
               <a:lnSpc>
                 <a:spcPts val="1700"/>
               </a:lnSpc>
@@ -5990,7 +5956,7 @@
           <a:bodyPr wrap="square" lIns="0" tIns="0" rIns="0" bIns="0" rtlCol="0" anchor="ctr"/>
           <a:lstStyle/>
           <a:p>
-            <a:pPr algn="ctr" indent="0" marL="0">
+            <a:pPr marL="0" indent="0" algn="ctr">
               <a:buNone/>
             </a:pPr>
             <a:r>
@@ -6034,6 +6000,13 @@
             <a:prstDash val="solid"/>
           </a:ln>
         </p:spPr>
+        <p:txBody>
+          <a:bodyPr/>
+          <a:lstStyle/>
+          <a:p>
+            <a:endParaRPr lang="en-GB"/>
+          </a:p>
+        </p:txBody>
       </p:sp>
       <p:sp>
         <p:nvSpPr>
@@ -6056,7 +6029,7 @@
           <a:bodyPr wrap="square" lIns="0" tIns="0" rIns="0" bIns="0" rtlCol="0" anchor="ctr"/>
           <a:lstStyle/>
           <a:p>
-            <a:pPr algn="ctr" indent="0" marL="0">
+            <a:pPr marL="0" indent="0" algn="ctr">
               <a:lnSpc>
                 <a:spcPts val="1700"/>
               </a:lnSpc>
@@ -6076,7 +6049,7 @@
             <a:endParaRPr lang="en-US" sz="1350" dirty="0"/>
           </a:p>
           <a:p>
-            <a:pPr algn="ctr" indent="0" marL="0">
+            <a:pPr marL="0" indent="0" algn="ctr">
               <a:lnSpc>
                 <a:spcPts val="1700"/>
               </a:lnSpc>
@@ -6118,7 +6091,7 @@
           <a:bodyPr wrap="square" lIns="0" tIns="0" rIns="0" bIns="0" rtlCol="0" anchor="ctr"/>
           <a:lstStyle/>
           <a:p>
-            <a:pPr algn="ctr" indent="0" marL="0">
+            <a:pPr marL="0" indent="0" algn="ctr">
               <a:buNone/>
             </a:pPr>
             <a:r>
@@ -6162,6 +6135,13 @@
             <a:prstDash val="solid"/>
           </a:ln>
         </p:spPr>
+        <p:txBody>
+          <a:bodyPr/>
+          <a:lstStyle/>
+          <a:p>
+            <a:endParaRPr lang="en-GB"/>
+          </a:p>
+        </p:txBody>
       </p:sp>
       <p:sp>
         <p:nvSpPr>
@@ -6184,7 +6164,7 @@
           <a:bodyPr wrap="square" lIns="0" tIns="0" rIns="0" bIns="0" rtlCol="0" anchor="ctr"/>
           <a:lstStyle/>
           <a:p>
-            <a:pPr algn="ctr" indent="0" marL="0">
+            <a:pPr marL="0" indent="0" algn="ctr">
               <a:lnSpc>
                 <a:spcPts val="1700"/>
               </a:lnSpc>
@@ -6204,7 +6184,7 @@
             <a:endParaRPr lang="en-US" sz="1350" dirty="0"/>
           </a:p>
           <a:p>
-            <a:pPr algn="ctr" indent="0" marL="0">
+            <a:pPr marL="0" indent="0" algn="ctr">
               <a:lnSpc>
                 <a:spcPts val="1700"/>
               </a:lnSpc>
@@ -6246,7 +6226,7 @@
           <a:bodyPr wrap="square" lIns="0" tIns="0" rIns="0" bIns="0" rtlCol="0" anchor="ctr"/>
           <a:lstStyle/>
           <a:p>
-            <a:pPr indent="0" marL="0">
+            <a:pPr marL="0" indent="0">
               <a:buNone/>
             </a:pPr>
             <a:r>
@@ -6290,6 +6270,13 @@
             <a:prstDash val="solid"/>
           </a:ln>
         </p:spPr>
+        <p:txBody>
+          <a:bodyPr/>
+          <a:lstStyle/>
+          <a:p>
+            <a:endParaRPr lang="en-GB"/>
+          </a:p>
+        </p:txBody>
       </p:sp>
       <p:sp>
         <p:nvSpPr>
@@ -6312,7 +6299,7 @@
           <a:bodyPr wrap="square" lIns="0" tIns="0" rIns="0" bIns="0" rtlCol="0" anchor="ctr"/>
           <a:lstStyle/>
           <a:p>
-            <a:pPr indent="0" marL="0">
+            <a:pPr marL="0" indent="0">
               <a:buNone/>
             </a:pPr>
             <a:r>
@@ -6351,7 +6338,7 @@
           <a:bodyPr wrap="square" lIns="0" tIns="0" rIns="0" bIns="0" rtlCol="0" anchor="ctr"/>
           <a:lstStyle/>
           <a:p>
-            <a:pPr indent="0" marL="0">
+            <a:pPr marL="0" indent="0">
               <a:buNone/>
             </a:pPr>
             <a:r>
@@ -6395,6 +6382,13 @@
             <a:prstDash val="solid"/>
           </a:ln>
         </p:spPr>
+        <p:txBody>
+          <a:bodyPr/>
+          <a:lstStyle/>
+          <a:p>
+            <a:endParaRPr lang="en-GB"/>
+          </a:p>
+        </p:txBody>
       </p:sp>
       <p:sp>
         <p:nvSpPr>
@@ -6417,7 +6411,7 @@
           <a:bodyPr wrap="square" lIns="0" tIns="0" rIns="0" bIns="0" rtlCol="0" anchor="ctr"/>
           <a:lstStyle/>
           <a:p>
-            <a:pPr indent="0" marL="0">
+            <a:pPr marL="0" indent="0">
               <a:buNone/>
             </a:pPr>
             <a:r>
@@ -6456,7 +6450,7 @@
           <a:bodyPr wrap="square" lIns="0" tIns="0" rIns="0" bIns="0" rtlCol="0" anchor="ctr"/>
           <a:lstStyle/>
           <a:p>
-            <a:pPr indent="0" marL="0">
+            <a:pPr marL="0" indent="0">
               <a:buNone/>
             </a:pPr>
             <a:r>
@@ -6495,7 +6489,7 @@
           <a:bodyPr wrap="square" lIns="0" tIns="0" rIns="0" bIns="0" rtlCol="0" anchor="ctr"/>
           <a:lstStyle/>
           <a:p>
-            <a:pPr indent="0" marL="0">
+            <a:pPr marL="0" indent="0">
               <a:buNone/>
             </a:pPr>
             <a:r>
@@ -6509,9 +6503,6 @@
               </a:rPr>
               <a:t>So the escalation says: </a:t>
             </a:r>
-            <a:pPr indent="0" marL="0">
-              <a:buNone/>
-            </a:pPr>
             <a:r>
               <a:rPr lang="en-US" sz="1350" b="1" dirty="0">
                 <a:solidFill>
@@ -6548,7 +6539,7 @@
           <a:bodyPr wrap="square" lIns="0" tIns="0" rIns="0" bIns="0" rtlCol="0" anchor="ctr"/>
           <a:lstStyle/>
           <a:p>
-            <a:pPr algn="l" indent="0" marL="0">
+            <a:pPr marL="0" indent="0" algn="l">
               <a:buNone/>
             </a:pPr>
             <a:r>
@@ -6587,7 +6578,7 @@
           <a:bodyPr wrap="square" lIns="0" tIns="0" rIns="0" bIns="0" rtlCol="0" anchor="ctr"/>
           <a:lstStyle/>
           <a:p>
-            <a:pPr algn="r" indent="0" marL="0">
+            <a:pPr marL="0" indent="0" algn="r">
               <a:buNone/>
             </a:pPr>
             <a:r>
@@ -6621,6 +6612,7 @@
         <a:solidFill>
           <a:srgbClr val="13453B"/>
         </a:solidFill>
+        <a:effectLst/>
       </p:bgPr>
     </p:bg>
     <p:spTree>
@@ -6658,11 +6650,11 @@
           <a:bodyPr wrap="square" lIns="0" tIns="0" rIns="0" bIns="0" rtlCol="0" anchor="ctr"/>
           <a:lstStyle/>
           <a:p>
-            <a:pPr indent="0" marL="0">
-              <a:buNone/>
-            </a:pPr>
-            <a:r>
-              <a:rPr lang="en-US" sz="1000" b="1" spc="220" kern="0" dirty="0">
+            <a:pPr marL="0" indent="0">
+              <a:buNone/>
+            </a:pPr>
+            <a:r>
+              <a:rPr lang="en-US" sz="1000" b="1" kern="0" spc="220" dirty="0">
                 <a:solidFill>
                   <a:srgbClr val="C8892F"/>
                 </a:solidFill>
@@ -6697,7 +6689,7 @@
           <a:bodyPr wrap="square" lIns="0" tIns="0" rIns="0" bIns="0" rtlCol="0" anchor="ctr"/>
           <a:lstStyle/>
           <a:p>
-            <a:pPr indent="0" marL="0">
+            <a:pPr marL="0" indent="0">
               <a:buNone/>
             </a:pPr>
             <a:r>
@@ -6736,7 +6728,7 @@
           <a:bodyPr wrap="square" lIns="0" tIns="0" rIns="0" bIns="0" rtlCol="0" anchor="ctr"/>
           <a:lstStyle/>
           <a:p>
-            <a:pPr indent="0" marL="0">
+            <a:pPr marL="0" indent="0">
               <a:buNone/>
             </a:pPr>
             <a:r>
@@ -6775,11 +6767,11 @@
           <a:bodyPr wrap="square" lIns="0" tIns="0" rIns="0" bIns="0" rtlCol="0" anchor="ctr"/>
           <a:lstStyle/>
           <a:p>
-            <a:pPr indent="0" marL="0">
-              <a:buNone/>
-            </a:pPr>
-            <a:r>
-              <a:rPr lang="en-US" sz="1100" b="1" spc="180" kern="0" dirty="0">
+            <a:pPr marL="0" indent="0">
+              <a:buNone/>
+            </a:pPr>
+            <a:r>
+              <a:rPr lang="en-US" sz="1100" b="1" kern="0" spc="180" dirty="0">
                 <a:solidFill>
                   <a:srgbClr val="C8892F"/>
                 </a:solidFill>
@@ -6932,11 +6924,11 @@
           <a:bodyPr wrap="square" lIns="0" tIns="0" rIns="0" bIns="0" rtlCol="0" anchor="ctr"/>
           <a:lstStyle/>
           <a:p>
-            <a:pPr indent="0" marL="0">
-              <a:buNone/>
-            </a:pPr>
-            <a:r>
-              <a:rPr lang="en-US" sz="1100" b="1" spc="180" kern="0" dirty="0">
+            <a:pPr marL="0" indent="0">
+              <a:buNone/>
+            </a:pPr>
+            <a:r>
+              <a:rPr lang="en-US" sz="1100" b="1" kern="0" spc="180" dirty="0">
                 <a:solidFill>
                   <a:srgbClr val="C8892F"/>
                 </a:solidFill>
@@ -7114,6 +7106,13 @@
             <a:prstDash val="solid"/>
           </a:ln>
         </p:spPr>
+        <p:txBody>
+          <a:bodyPr/>
+          <a:lstStyle/>
+          <a:p>
+            <a:endParaRPr lang="en-GB"/>
+          </a:p>
+        </p:txBody>
       </p:sp>
       <p:sp>
         <p:nvSpPr>
@@ -7136,7 +7135,7 @@
           <a:bodyPr wrap="square" lIns="0" tIns="0" rIns="0" bIns="0" rtlCol="0" anchor="ctr"/>
           <a:lstStyle/>
           <a:p>
-            <a:pPr indent="0" marL="0">
+            <a:pPr marL="0" indent="0">
               <a:buNone/>
             </a:pPr>
             <a:r>
@@ -7175,7 +7174,7 @@
           <a:bodyPr wrap="square" lIns="0" tIns="0" rIns="0" bIns="0" rtlCol="0" anchor="t"/>
           <a:lstStyle/>
           <a:p>
-            <a:pPr indent="0" marL="0">
+            <a:pPr marL="0" indent="0">
               <a:lnSpc>
                 <a:spcPts val="3000"/>
               </a:lnSpc>
@@ -7217,7 +7216,7 @@
           <a:bodyPr wrap="square" lIns="0" tIns="0" rIns="0" bIns="0" rtlCol="0" anchor="ctr"/>
           <a:lstStyle/>
           <a:p>
-            <a:pPr algn="l" indent="0" marL="0">
+            <a:pPr marL="0" indent="0" algn="l">
               <a:buNone/>
             </a:pPr>
             <a:r>
@@ -7256,7 +7255,7 @@
           <a:bodyPr wrap="square" lIns="0" tIns="0" rIns="0" bIns="0" rtlCol="0" anchor="ctr"/>
           <a:lstStyle/>
           <a:p>
-            <a:pPr algn="r" indent="0" marL="0">
+            <a:pPr marL="0" indent="0" algn="r">
               <a:buNone/>
             </a:pPr>
             <a:r>
@@ -7575,4 +7574,325 @@
     </a:ext>
   </a:extLst>
 </a:theme>
+</file>
+
+<file path=ppt/theme/theme2.xml><?xml version="1.0" encoding="utf-8"?>
+<a:theme xmlns:a="http://schemas.openxmlformats.org/drawingml/2006/main" name="Office Theme">
+  <a:themeElements>
+    <a:clrScheme name="Office">
+      <a:dk1>
+        <a:sysClr val="windowText" lastClr="000000"/>
+      </a:dk1>
+      <a:lt1>
+        <a:sysClr val="window" lastClr="FFFFFF"/>
+      </a:lt1>
+      <a:dk2>
+        <a:srgbClr val="0E2841"/>
+      </a:dk2>
+      <a:lt2>
+        <a:srgbClr val="E8E8E8"/>
+      </a:lt2>
+      <a:accent1>
+        <a:srgbClr val="156082"/>
+      </a:accent1>
+      <a:accent2>
+        <a:srgbClr val="E97132"/>
+      </a:accent2>
+      <a:accent3>
+        <a:srgbClr val="196B24"/>
+      </a:accent3>
+      <a:accent4>
+        <a:srgbClr val="0F9ED5"/>
+      </a:accent4>
+      <a:accent5>
+        <a:srgbClr val="A02B93"/>
+      </a:accent5>
+      <a:accent6>
+        <a:srgbClr val="4EA72E"/>
+      </a:accent6>
+      <a:hlink>
+        <a:srgbClr val="467886"/>
+      </a:hlink>
+      <a:folHlink>
+        <a:srgbClr val="96607D"/>
+      </a:folHlink>
+    </a:clrScheme>
+    <a:fontScheme name="Office">
+      <a:majorFont>
+        <a:latin typeface="Aptos Display" panose="02110004020202020204"/>
+        <a:ea typeface=""/>
+        <a:cs typeface=""/>
+        <a:font script="Jpan" typeface="游ゴシック Light"/>
+        <a:font script="Hang" typeface="맑은 고딕"/>
+        <a:font script="Hans" typeface="等线 Light"/>
+        <a:font script="Hant" typeface="新細明體"/>
+        <a:font script="Arab" typeface="Times New Roman"/>
+        <a:font script="Hebr" typeface="Times New Roman"/>
+        <a:font script="Thai" typeface="Angsana New"/>
+        <a:font script="Ethi" typeface="Nyala"/>
+        <a:font script="Beng" typeface="Vrinda"/>
+        <a:font script="Gujr" typeface="Shruti"/>
+        <a:font script="Khmr" typeface="MoolBoran"/>
+        <a:font script="Knda" typeface="Tunga"/>
+        <a:font script="Guru" typeface="Raavi"/>
+        <a:font script="Cans" typeface="Euphemia"/>
+        <a:font script="Cher" typeface="Plantagenet Cherokee"/>
+        <a:font script="Yiii" typeface="Microsoft Yi Baiti"/>
+        <a:font script="Tibt" typeface="Microsoft Himalaya"/>
+        <a:font script="Thaa" typeface="MV Boli"/>
+        <a:font script="Deva" typeface="Mangal"/>
+        <a:font script="Telu" typeface="Gautami"/>
+        <a:font script="Taml" typeface="Latha"/>
+        <a:font script="Syrc" typeface="Estrangelo Edessa"/>
+        <a:font script="Orya" typeface="Kalinga"/>
+        <a:font script="Mlym" typeface="Kartika"/>
+        <a:font script="Laoo" typeface="DokChampa"/>
+        <a:font script="Sinh" typeface="Iskoola Pota"/>
+        <a:font script="Mong" typeface="Mongolian Baiti"/>
+        <a:font script="Viet" typeface="Times New Roman"/>
+        <a:font script="Uigh" typeface="Microsoft Uighur"/>
+        <a:font script="Geor" typeface="Sylfaen"/>
+        <a:font script="Armn" typeface="Arial"/>
+        <a:font script="Bugi" typeface="Leelawadee UI"/>
+        <a:font script="Bopo" typeface="Microsoft JhengHei"/>
+        <a:font script="Java" typeface="Javanese Text"/>
+        <a:font script="Lisu" typeface="Segoe UI"/>
+        <a:font script="Mymr" typeface="Myanmar Text"/>
+        <a:font script="Nkoo" typeface="Ebrima"/>
+        <a:font script="Olck" typeface="Nirmala UI"/>
+        <a:font script="Osma" typeface="Ebrima"/>
+        <a:font script="Phag" typeface="Phagspa"/>
+        <a:font script="Syrn" typeface="Estrangelo Edessa"/>
+        <a:font script="Syrj" typeface="Estrangelo Edessa"/>
+        <a:font script="Syre" typeface="Estrangelo Edessa"/>
+        <a:font script="Sora" typeface="Nirmala UI"/>
+        <a:font script="Tale" typeface="Microsoft Tai Le"/>
+        <a:font script="Talu" typeface="Microsoft New Tai Lue"/>
+        <a:font script="Tfng" typeface="Ebrima"/>
+      </a:majorFont>
+      <a:minorFont>
+        <a:latin typeface="Aptos" panose="02110004020202020204"/>
+        <a:ea typeface=""/>
+        <a:cs typeface=""/>
+        <a:font script="Jpan" typeface="游ゴシック"/>
+        <a:font script="Hang" typeface="맑은 고딕"/>
+        <a:font script="Hans" typeface="等线"/>
+        <a:font script="Hant" typeface="新細明體"/>
+        <a:font script="Arab" typeface="Arial"/>
+        <a:font script="Hebr" typeface="Arial"/>
+        <a:font script="Thai" typeface="Cordia New"/>
+        <a:font script="Ethi" typeface="Nyala"/>
+        <a:font script="Beng" typeface="Vrinda"/>
+        <a:font script="Gujr" typeface="Shruti"/>
+        <a:font script="Khmr" typeface="DaunPenh"/>
+        <a:font script="Knda" typeface="Tunga"/>
+        <a:font script="Guru" typeface="Raavi"/>
+        <a:font script="Cans" typeface="Euphemia"/>
+        <a:font script="Cher" typeface="Plantagenet Cherokee"/>
+        <a:font script="Yiii" typeface="Microsoft Yi Baiti"/>
+        <a:font script="Tibt" typeface="Microsoft Himalaya"/>
+        <a:font script="Thaa" typeface="MV Boli"/>
+        <a:font script="Deva" typeface="Mangal"/>
+        <a:font script="Telu" typeface="Gautami"/>
+        <a:font script="Taml" typeface="Latha"/>
+        <a:font script="Syrc" typeface="Estrangelo Edessa"/>
+        <a:font script="Orya" typeface="Kalinga"/>
+        <a:font script="Mlym" typeface="Kartika"/>
+        <a:font script="Laoo" typeface="DokChampa"/>
+        <a:font script="Sinh" typeface="Iskoola Pota"/>
+        <a:font script="Mong" typeface="Mongolian Baiti"/>
+        <a:font script="Viet" typeface="Arial"/>
+        <a:font script="Uigh" typeface="Microsoft Uighur"/>
+        <a:font script="Geor" typeface="Sylfaen"/>
+        <a:font script="Armn" typeface="Arial"/>
+        <a:font script="Bugi" typeface="Leelawadee UI"/>
+        <a:font script="Bopo" typeface="Microsoft JhengHei"/>
+        <a:font script="Java" typeface="Javanese Text"/>
+        <a:font script="Lisu" typeface="Segoe UI"/>
+        <a:font script="Mymr" typeface="Myanmar Text"/>
+        <a:font script="Nkoo" typeface="Ebrima"/>
+        <a:font script="Olck" typeface="Nirmala UI"/>
+        <a:font script="Osma" typeface="Ebrima"/>
+        <a:font script="Phag" typeface="Phagspa"/>
+        <a:font script="Syrn" typeface="Estrangelo Edessa"/>
+        <a:font script="Syrj" typeface="Estrangelo Edessa"/>
+        <a:font script="Syre" typeface="Estrangelo Edessa"/>
+        <a:font script="Sora" typeface="Nirmala UI"/>
+        <a:font script="Tale" typeface="Microsoft Tai Le"/>
+        <a:font script="Talu" typeface="Microsoft New Tai Lue"/>
+        <a:font script="Tfng" typeface="Ebrima"/>
+      </a:minorFont>
+    </a:fontScheme>
+    <a:fmtScheme name="Office">
+      <a:fillStyleLst>
+        <a:solidFill>
+          <a:schemeClr val="phClr"/>
+        </a:solidFill>
+        <a:gradFill rotWithShape="1">
+          <a:gsLst>
+            <a:gs pos="0">
+              <a:schemeClr val="phClr">
+                <a:lumMod val="110000"/>
+                <a:satMod val="105000"/>
+                <a:tint val="67000"/>
+              </a:schemeClr>
+            </a:gs>
+            <a:gs pos="50000">
+              <a:schemeClr val="phClr">
+                <a:lumMod val="105000"/>
+                <a:satMod val="103000"/>
+                <a:tint val="73000"/>
+              </a:schemeClr>
+            </a:gs>
+            <a:gs pos="100000">
+              <a:schemeClr val="phClr">
+                <a:lumMod val="105000"/>
+                <a:satMod val="109000"/>
+                <a:tint val="81000"/>
+              </a:schemeClr>
+            </a:gs>
+          </a:gsLst>
+          <a:lin ang="5400000" scaled="0"/>
+        </a:gradFill>
+        <a:gradFill rotWithShape="1">
+          <a:gsLst>
+            <a:gs pos="0">
+              <a:schemeClr val="phClr">
+                <a:satMod val="103000"/>
+                <a:lumMod val="102000"/>
+                <a:tint val="94000"/>
+              </a:schemeClr>
+            </a:gs>
+            <a:gs pos="50000">
+              <a:schemeClr val="phClr">
+                <a:satMod val="110000"/>
+                <a:lumMod val="100000"/>
+                <a:shade val="100000"/>
+              </a:schemeClr>
+            </a:gs>
+            <a:gs pos="100000">
+              <a:schemeClr val="phClr">
+                <a:lumMod val="99000"/>
+                <a:satMod val="120000"/>
+                <a:shade val="78000"/>
+              </a:schemeClr>
+            </a:gs>
+          </a:gsLst>
+          <a:lin ang="5400000" scaled="0"/>
+        </a:gradFill>
+      </a:fillStyleLst>
+      <a:lnStyleLst>
+        <a:ln w="12700" cap="flat" cmpd="sng" algn="ctr">
+          <a:solidFill>
+            <a:schemeClr val="phClr"/>
+          </a:solidFill>
+          <a:prstDash val="solid"/>
+          <a:miter lim="800000"/>
+        </a:ln>
+        <a:ln w="19050" cap="flat" cmpd="sng" algn="ctr">
+          <a:solidFill>
+            <a:schemeClr val="phClr"/>
+          </a:solidFill>
+          <a:prstDash val="solid"/>
+          <a:miter lim="800000"/>
+        </a:ln>
+        <a:ln w="25400" cap="flat" cmpd="sng" algn="ctr">
+          <a:solidFill>
+            <a:schemeClr val="phClr"/>
+          </a:solidFill>
+          <a:prstDash val="solid"/>
+          <a:miter lim="800000"/>
+        </a:ln>
+      </a:lnStyleLst>
+      <a:effectStyleLst>
+        <a:effectStyle>
+          <a:effectLst/>
+        </a:effectStyle>
+        <a:effectStyle>
+          <a:effectLst/>
+        </a:effectStyle>
+        <a:effectStyle>
+          <a:effectLst>
+            <a:outerShdw blurRad="57150" dist="19050" dir="5400000" algn="ctr" rotWithShape="0">
+              <a:srgbClr val="000000">
+                <a:alpha val="63000"/>
+              </a:srgbClr>
+            </a:outerShdw>
+          </a:effectLst>
+        </a:effectStyle>
+      </a:effectStyleLst>
+      <a:bgFillStyleLst>
+        <a:solidFill>
+          <a:schemeClr val="phClr"/>
+        </a:solidFill>
+        <a:solidFill>
+          <a:schemeClr val="phClr">
+            <a:tint val="95000"/>
+            <a:satMod val="170000"/>
+          </a:schemeClr>
+        </a:solidFill>
+        <a:gradFill rotWithShape="1">
+          <a:gsLst>
+            <a:gs pos="0">
+              <a:schemeClr val="phClr">
+                <a:tint val="93000"/>
+                <a:satMod val="150000"/>
+                <a:shade val="98000"/>
+                <a:lumMod val="102000"/>
+              </a:schemeClr>
+            </a:gs>
+            <a:gs pos="50000">
+              <a:schemeClr val="phClr">
+                <a:tint val="98000"/>
+                <a:satMod val="130000"/>
+                <a:shade val="90000"/>
+                <a:lumMod val="103000"/>
+              </a:schemeClr>
+            </a:gs>
+            <a:gs pos="100000">
+              <a:schemeClr val="phClr">
+                <a:shade val="63000"/>
+                <a:satMod val="120000"/>
+              </a:schemeClr>
+            </a:gs>
+          </a:gsLst>
+          <a:lin ang="5400000" scaled="0"/>
+        </a:gradFill>
+      </a:bgFillStyleLst>
+    </a:fmtScheme>
+  </a:themeElements>
+  <a:objectDefaults>
+    <a:lnDef>
+      <a:spPr/>
+      <a:bodyPr/>
+      <a:lstStyle/>
+      <a:style>
+        <a:lnRef idx="2">
+          <a:schemeClr val="accent1"/>
+        </a:lnRef>
+        <a:fillRef idx="0">
+          <a:schemeClr val="accent1"/>
+        </a:fillRef>
+        <a:effectRef idx="1">
+          <a:schemeClr val="accent1"/>
+        </a:effectRef>
+        <a:fontRef idx="minor">
+          <a:schemeClr val="tx1"/>
+        </a:fontRef>
+      </a:style>
+    </a:lnDef>
+  </a:objectDefaults>
+  <a:extraClrSchemeLst/>
+  <a:extLst>
+    <a:ext uri="{05A4C25C-085E-4340-85A3-A5531E510DB2}">
+      <thm15:themeFamily xmlns:thm15="http://schemas.microsoft.com/office/thememl/2012/main" name="Office Theme" id="{2E142A2C-CD16-42D6-873A-C26D2A0506FA}" vid="{1BDDFF52-6CD6-40A5-AB3C-68EB2F1E4D0A}"/>
+    </a:ext>
+  </a:extLst>
+</a:theme>
+</file>
+
+<file path=docMetadata/LabelInfo.xml><?xml version="1.0" encoding="utf-8"?>
+<clbl:labelList xmlns:clbl="http://schemas.microsoft.com/office/2020/mipLabelMetadata">
+  <clbl:label id="{2e8712ce-4b1c-42f0-8103-696d10633cf9}" enabled="1" method="Privileged" siteId="{ddd66cce-ffe1-4029-967c-5e15ef73127f}" contentBits="3" removed="0"/>
+</clbl:labelList>
 </file>
</xml_diff>